<commit_message>
Refresh pitch, investor brief, and portal brand for submission.
Keep the hand-updated pitch deck and sync clearer figures, PoC links, and the gold clover favicon without regenerating the PPT.

Co-authored-by: Cursor <cursoragent@cursor.com>
</commit_message>
<xml_diff>
--- a/ElimuMatch_Executive_Pitch.pptx
+++ b/ElimuMatch_Executive_Pitch.pptx
@@ -136,19 +136,27 @@
 <pc:chgInfo xmlns:a="http://schemas.openxmlformats.org/drawingml/2006/main" xmlns:r="http://schemas.openxmlformats.org/officeDocument/2006/relationships" xmlns:ac="http://schemas.microsoft.com/office/drawing/2013/main/command" xmlns:pc="http://schemas.microsoft.com/office/powerpoint/2013/main/command">
   <pc:docChgLst>
     <pc:chgData name="Jess W" userId="0a9e92bfc7a9bd4f" providerId="LiveId" clId="{44A44528-DB36-4F8C-9869-CF35F0FB3EAC}"/>
-    <pc:docChg chg="undo custSel modSld">
-      <pc:chgData name="Jess W" userId="0a9e92bfc7a9bd4f" providerId="LiveId" clId="{44A44528-DB36-4F8C-9869-CF35F0FB3EAC}" dt="2026-09-04T20:06:49.613" v="137" actId="20577"/>
+    <pc:docChg chg="undo redo custSel addSld delSld modSld">
+      <pc:chgData name="Jess W" userId="0a9e92bfc7a9bd4f" providerId="LiveId" clId="{44A44528-DB36-4F8C-9869-CF35F0FB3EAC}" dt="2026-09-08T19:51:01.266" v="663" actId="1076"/>
       <pc:docMkLst>
         <pc:docMk/>
       </pc:docMkLst>
-      <pc:sldChg chg="modSp mod">
-        <pc:chgData name="Jess W" userId="0a9e92bfc7a9bd4f" providerId="LiveId" clId="{44A44528-DB36-4F8C-9869-CF35F0FB3EAC}" dt="2026-09-04T20:01:41.200" v="127" actId="20577"/>
+      <pc:sldChg chg="addSp delSp modSp mod">
+        <pc:chgData name="Jess W" userId="0a9e92bfc7a9bd4f" providerId="LiveId" clId="{44A44528-DB36-4F8C-9869-CF35F0FB3EAC}" dt="2026-09-08T10:06:32.233" v="96" actId="20577"/>
         <pc:sldMkLst>
           <pc:docMk/>
           <pc:sldMk cId="0" sldId="256"/>
         </pc:sldMkLst>
         <pc:spChg chg="mod">
-          <ac:chgData name="Jess W" userId="0a9e92bfc7a9bd4f" providerId="LiveId" clId="{44A44528-DB36-4F8C-9869-CF35F0FB3EAC}" dt="2026-09-04T20:01:41.200" v="127" actId="20577"/>
+          <ac:chgData name="Jess W" userId="0a9e92bfc7a9bd4f" providerId="LiveId" clId="{44A44528-DB36-4F8C-9869-CF35F0FB3EAC}" dt="2026-09-08T09:26:33.148" v="45" actId="1076"/>
+          <ac:spMkLst>
+            <pc:docMk/>
+            <pc:sldMk cId="0" sldId="256"/>
+            <ac:spMk id="4" creationId="{00000000-0000-0000-0000-000000000000}"/>
+          </ac:spMkLst>
+        </pc:spChg>
+        <pc:spChg chg="mod">
+          <ac:chgData name="Jess W" userId="0a9e92bfc7a9bd4f" providerId="LiveId" clId="{44A44528-DB36-4F8C-9869-CF35F0FB3EAC}" dt="2026-09-08T10:06:32.233" v="96" actId="20577"/>
           <ac:spMkLst>
             <pc:docMk/>
             <pc:sldMk cId="0" sldId="256"/>
@@ -156,7 +164,7 @@
           </ac:spMkLst>
         </pc:spChg>
         <pc:spChg chg="mod">
-          <ac:chgData name="Jess W" userId="0a9e92bfc7a9bd4f" providerId="LiveId" clId="{44A44528-DB36-4F8C-9869-CF35F0FB3EAC}" dt="2026-09-04T19:45:10.437" v="60" actId="20577"/>
+          <ac:chgData name="Jess W" userId="0a9e92bfc7a9bd4f" providerId="LiveId" clId="{44A44528-DB36-4F8C-9869-CF35F0FB3EAC}" dt="2026-09-08T10:05:37.196" v="73" actId="1076"/>
           <ac:spMkLst>
             <pc:docMk/>
             <pc:sldMk cId="0" sldId="256"/>
@@ -164,22 +172,54 @@
           </ac:spMkLst>
         </pc:spChg>
         <pc:spChg chg="mod">
-          <ac:chgData name="Jess W" userId="0a9e92bfc7a9bd4f" providerId="LiveId" clId="{44A44528-DB36-4F8C-9869-CF35F0FB3EAC}" dt="2026-09-04T19:44:55.947" v="58" actId="1076"/>
+          <ac:chgData name="Jess W" userId="0a9e92bfc7a9bd4f" providerId="LiveId" clId="{44A44528-DB36-4F8C-9869-CF35F0FB3EAC}" dt="2026-09-08T10:05:33.055" v="72" actId="1076"/>
           <ac:spMkLst>
             <pc:docMk/>
             <pc:sldMk cId="0" sldId="256"/>
             <ac:spMk id="9" creationId="{00000000-0000-0000-0000-000000000000}"/>
           </ac:spMkLst>
         </pc:spChg>
+        <pc:spChg chg="del">
+          <ac:chgData name="Jess W" userId="0a9e92bfc7a9bd4f" providerId="LiveId" clId="{44A44528-DB36-4F8C-9869-CF35F0FB3EAC}" dt="2026-09-08T09:23:38.824" v="27" actId="478"/>
+          <ac:spMkLst>
+            <pc:docMk/>
+            <pc:sldMk cId="0" sldId="256"/>
+            <ac:spMk id="13" creationId="{00000000-0000-0000-0000-000000000000}"/>
+          </ac:spMkLst>
+        </pc:spChg>
+        <pc:picChg chg="add del mod">
+          <ac:chgData name="Jess W" userId="0a9e92bfc7a9bd4f" providerId="LiveId" clId="{44A44528-DB36-4F8C-9869-CF35F0FB3EAC}" dt="2026-09-08T09:26:22.909" v="41" actId="478"/>
+          <ac:picMkLst>
+            <pc:docMk/>
+            <pc:sldMk cId="0" sldId="256"/>
+            <ac:picMk id="10" creationId="{00000000-0000-0000-0000-000000000000}"/>
+          </ac:picMkLst>
+        </pc:picChg>
+        <pc:picChg chg="mod">
+          <ac:chgData name="Jess W" userId="0a9e92bfc7a9bd4f" providerId="LiveId" clId="{44A44528-DB36-4F8C-9869-CF35F0FB3EAC}" dt="2026-09-08T10:04:02.429" v="49" actId="14100"/>
+          <ac:picMkLst>
+            <pc:docMk/>
+            <pc:sldMk cId="0" sldId="256"/>
+            <ac:picMk id="11" creationId="{00000000-0000-0000-0000-000000000000}"/>
+          </ac:picMkLst>
+        </pc:picChg>
+        <pc:picChg chg="add del">
+          <ac:chgData name="Jess W" userId="0a9e92bfc7a9bd4f" providerId="LiveId" clId="{44A44528-DB36-4F8C-9869-CF35F0FB3EAC}" dt="2026-09-08T09:26:22.385" v="40" actId="478"/>
+          <ac:picMkLst>
+            <pc:docMk/>
+            <pc:sldMk cId="0" sldId="256"/>
+            <ac:picMk id="12" creationId="{00000000-0000-0000-0000-000000000000}"/>
+          </ac:picMkLst>
+        </pc:picChg>
       </pc:sldChg>
       <pc:sldChg chg="modSp mod">
-        <pc:chgData name="Jess W" userId="0a9e92bfc7a9bd4f" providerId="LiveId" clId="{44A44528-DB36-4F8C-9869-CF35F0FB3EAC}" dt="2026-09-04T20:02:35.120" v="131" actId="20577"/>
+        <pc:chgData name="Jess W" userId="0a9e92bfc7a9bd4f" providerId="LiveId" clId="{44A44528-DB36-4F8C-9869-CF35F0FB3EAC}" dt="2026-09-08T08:59:24.351" v="1" actId="1076"/>
         <pc:sldMkLst>
           <pc:docMk/>
           <pc:sldMk cId="0" sldId="257"/>
         </pc:sldMkLst>
         <pc:spChg chg="mod">
-          <ac:chgData name="Jess W" userId="0a9e92bfc7a9bd4f" providerId="LiveId" clId="{44A44528-DB36-4F8C-9869-CF35F0FB3EAC}" dt="2026-09-04T20:02:35.120" v="131" actId="20577"/>
+          <ac:chgData name="Jess W" userId="0a9e92bfc7a9bd4f" providerId="LiveId" clId="{44A44528-DB36-4F8C-9869-CF35F0FB3EAC}" dt="2026-09-08T08:59:24.351" v="1" actId="1076"/>
           <ac:spMkLst>
             <pc:docMk/>
             <pc:sldMk cId="0" sldId="257"/>
@@ -187,14 +227,22 @@
           </ac:spMkLst>
         </pc:spChg>
       </pc:sldChg>
-      <pc:sldChg chg="delSp modSp mod">
-        <pc:chgData name="Jess W" userId="0a9e92bfc7a9bd4f" providerId="LiveId" clId="{44A44528-DB36-4F8C-9869-CF35F0FB3EAC}" dt="2026-09-04T20:06:27.259" v="134" actId="1076"/>
+      <pc:sldChg chg="addSp delSp modSp mod">
+        <pc:chgData name="Jess W" userId="0a9e92bfc7a9bd4f" providerId="LiveId" clId="{44A44528-DB36-4F8C-9869-CF35F0FB3EAC}" dt="2026-09-08T19:11:03.623" v="598" actId="20577"/>
         <pc:sldMkLst>
           <pc:docMk/>
           <pc:sldMk cId="0" sldId="258"/>
         </pc:sldMkLst>
         <pc:spChg chg="mod">
-          <ac:chgData name="Jess W" userId="0a9e92bfc7a9bd4f" providerId="LiveId" clId="{44A44528-DB36-4F8C-9869-CF35F0FB3EAC}" dt="2026-09-04T20:06:27.259" v="134" actId="1076"/>
+          <ac:chgData name="Jess W" userId="0a9e92bfc7a9bd4f" providerId="LiveId" clId="{44A44528-DB36-4F8C-9869-CF35F0FB3EAC}" dt="2026-09-08T08:59:30.453" v="2" actId="1076"/>
+          <ac:spMkLst>
+            <pc:docMk/>
+            <pc:sldMk cId="0" sldId="258"/>
+            <ac:spMk id="5" creationId="{00000000-0000-0000-0000-000000000000}"/>
+          </ac:spMkLst>
+        </pc:spChg>
+        <pc:spChg chg="mod">
+          <ac:chgData name="Jess W" userId="0a9e92bfc7a9bd4f" providerId="LiveId" clId="{44A44528-DB36-4F8C-9869-CF35F0FB3EAC}" dt="2026-09-08T19:11:03.623" v="598" actId="20577"/>
           <ac:spMkLst>
             <pc:docMk/>
             <pc:sldMk cId="0" sldId="258"/>
@@ -202,22 +250,78 @@
           </ac:spMkLst>
         </pc:spChg>
         <pc:spChg chg="del">
-          <ac:chgData name="Jess W" userId="0a9e92bfc7a9bd4f" providerId="LiveId" clId="{44A44528-DB36-4F8C-9869-CF35F0FB3EAC}" dt="2026-09-04T20:06:17.389" v="132" actId="478"/>
+          <ac:chgData name="Jess W" userId="0a9e92bfc7a9bd4f" providerId="LiveId" clId="{44A44528-DB36-4F8C-9869-CF35F0FB3EAC}" dt="2026-09-08T09:00:44.473" v="7" actId="478"/>
           <ac:spMkLst>
             <pc:docMk/>
             <pc:sldMk cId="0" sldId="258"/>
             <ac:spMk id="8" creationId="{00000000-0000-0000-0000-000000000000}"/>
           </ac:spMkLst>
         </pc:spChg>
+        <pc:spChg chg="add">
+          <ac:chgData name="Jess W" userId="0a9e92bfc7a9bd4f" providerId="LiveId" clId="{44A44528-DB36-4F8C-9869-CF35F0FB3EAC}" dt="2026-09-08T16:14:57.499" v="492"/>
+          <ac:spMkLst>
+            <pc:docMk/>
+            <pc:sldMk cId="0" sldId="258"/>
+            <ac:spMk id="8" creationId="{0A497DB0-278A-B4FE-F703-19DD0C1E0E4E}"/>
+          </ac:spMkLst>
+        </pc:spChg>
+        <pc:spChg chg="add">
+          <ac:chgData name="Jess W" userId="0a9e92bfc7a9bd4f" providerId="LiveId" clId="{44A44528-DB36-4F8C-9869-CF35F0FB3EAC}" dt="2026-09-08T16:24:07.401" v="512"/>
+          <ac:spMkLst>
+            <pc:docMk/>
+            <pc:sldMk cId="0" sldId="258"/>
+            <ac:spMk id="9" creationId="{0C6C29B7-605F-833B-231D-82B20040C9C7}"/>
+          </ac:spMkLst>
+        </pc:spChg>
+        <pc:picChg chg="add del mod">
+          <ac:chgData name="Jess W" userId="0a9e92bfc7a9bd4f" providerId="LiveId" clId="{44A44528-DB36-4F8C-9869-CF35F0FB3EAC}" dt="2026-09-08T10:12:57.129" v="100" actId="478"/>
+          <ac:picMkLst>
+            <pc:docMk/>
+            <pc:sldMk cId="0" sldId="258"/>
+            <ac:picMk id="8" creationId="{8E1956F0-2089-DAC7-601C-6E6B5D6A4B6D}"/>
+          </ac:picMkLst>
+        </pc:picChg>
+        <pc:picChg chg="add del mod">
+          <ac:chgData name="Jess W" userId="0a9e92bfc7a9bd4f" providerId="LiveId" clId="{44A44528-DB36-4F8C-9869-CF35F0FB3EAC}" dt="2026-09-08T10:15:38.970" v="219" actId="478"/>
+          <ac:picMkLst>
+            <pc:docMk/>
+            <pc:sldMk cId="0" sldId="258"/>
+            <ac:picMk id="9" creationId="{AA8A7659-DD38-4C1E-BA62-CE6F9188D6BF}"/>
+          </ac:picMkLst>
+        </pc:picChg>
       </pc:sldChg>
-      <pc:sldChg chg="modSp mod">
-        <pc:chgData name="Jess W" userId="0a9e92bfc7a9bd4f" providerId="LiveId" clId="{44A44528-DB36-4F8C-9869-CF35F0FB3EAC}" dt="2026-09-04T20:06:49.613" v="137" actId="20577"/>
+      <pc:sldChg chg="delSp modSp mod">
+        <pc:chgData name="Jess W" userId="0a9e92bfc7a9bd4f" providerId="LiveId" clId="{44A44528-DB36-4F8C-9869-CF35F0FB3EAC}" dt="2026-09-08T19:20:46.332" v="600" actId="20577"/>
         <pc:sldMkLst>
           <pc:docMk/>
           <pc:sldMk cId="0" sldId="259"/>
         </pc:sldMkLst>
         <pc:spChg chg="mod">
-          <ac:chgData name="Jess W" userId="0a9e92bfc7a9bd4f" providerId="LiveId" clId="{44A44528-DB36-4F8C-9869-CF35F0FB3EAC}" dt="2026-09-04T20:06:49.613" v="137" actId="20577"/>
+          <ac:chgData name="Jess W" userId="0a9e92bfc7a9bd4f" providerId="LiveId" clId="{44A44528-DB36-4F8C-9869-CF35F0FB3EAC}" dt="2026-09-08T09:02:54.464" v="19" actId="1076"/>
+          <ac:spMkLst>
+            <pc:docMk/>
+            <pc:sldMk cId="0" sldId="259"/>
+            <ac:spMk id="4" creationId="{00000000-0000-0000-0000-000000000000}"/>
+          </ac:spMkLst>
+        </pc:spChg>
+        <pc:spChg chg="mod">
+          <ac:chgData name="Jess W" userId="0a9e92bfc7a9bd4f" providerId="LiveId" clId="{44A44528-DB36-4F8C-9869-CF35F0FB3EAC}" dt="2026-09-08T09:02:51.215" v="18" actId="1076"/>
+          <ac:spMkLst>
+            <pc:docMk/>
+            <pc:sldMk cId="0" sldId="259"/>
+            <ac:spMk id="5" creationId="{00000000-0000-0000-0000-000000000000}"/>
+          </ac:spMkLst>
+        </pc:spChg>
+        <pc:spChg chg="mod">
+          <ac:chgData name="Jess W" userId="0a9e92bfc7a9bd4f" providerId="LiveId" clId="{44A44528-DB36-4F8C-9869-CF35F0FB3EAC}" dt="2026-09-08T19:20:46.332" v="600" actId="20577"/>
+          <ac:spMkLst>
+            <pc:docMk/>
+            <pc:sldMk cId="0" sldId="259"/>
+            <ac:spMk id="7" creationId="{00000000-0000-0000-0000-000000000000}"/>
+          </ac:spMkLst>
+        </pc:spChg>
+        <pc:spChg chg="del">
+          <ac:chgData name="Jess W" userId="0a9e92bfc7a9bd4f" providerId="LiveId" clId="{44A44528-DB36-4F8C-9869-CF35F0FB3EAC}" dt="2026-09-08T09:00:58.376" v="8" actId="478"/>
           <ac:spMkLst>
             <pc:docMk/>
             <pc:sldMk cId="0" sldId="259"/>
@@ -226,28 +330,83 @@
         </pc:spChg>
       </pc:sldChg>
       <pc:sldChg chg="modSp mod">
-        <pc:chgData name="Jess W" userId="0a9e92bfc7a9bd4f" providerId="LiveId" clId="{44A44528-DB36-4F8C-9869-CF35F0FB3EAC}" dt="2026-09-04T19:43:16.883" v="13" actId="20577"/>
+        <pc:chgData name="Jess W" userId="0a9e92bfc7a9bd4f" providerId="LiveId" clId="{44A44528-DB36-4F8C-9869-CF35F0FB3EAC}" dt="2026-09-08T09:02:37.061" v="17" actId="1076"/>
+        <pc:sldMkLst>
+          <pc:docMk/>
+          <pc:sldMk cId="0" sldId="260"/>
+        </pc:sldMkLst>
+        <pc:picChg chg="mod">
+          <ac:chgData name="Jess W" userId="0a9e92bfc7a9bd4f" providerId="LiveId" clId="{44A44528-DB36-4F8C-9869-CF35F0FB3EAC}" dt="2026-09-08T09:02:37.061" v="17" actId="1076"/>
+          <ac:picMkLst>
+            <pc:docMk/>
+            <pc:sldMk cId="0" sldId="260"/>
+            <ac:picMk id="6" creationId="{00000000-0000-0000-0000-000000000000}"/>
+          </ac:picMkLst>
+        </pc:picChg>
+      </pc:sldChg>
+      <pc:sldChg chg="delSp modSp mod">
+        <pc:chgData name="Jess W" userId="0a9e92bfc7a9bd4f" providerId="LiveId" clId="{44A44528-DB36-4F8C-9869-CF35F0FB3EAC}" dt="2026-09-08T10:16:27.213" v="227" actId="123"/>
         <pc:sldMkLst>
           <pc:docMk/>
           <pc:sldMk cId="0" sldId="261"/>
         </pc:sldMkLst>
         <pc:spChg chg="mod">
-          <ac:chgData name="Jess W" userId="0a9e92bfc7a9bd4f" providerId="LiveId" clId="{44A44528-DB36-4F8C-9869-CF35F0FB3EAC}" dt="2026-09-04T19:43:16.883" v="13" actId="20577"/>
+          <ac:chgData name="Jess W" userId="0a9e92bfc7a9bd4f" providerId="LiveId" clId="{44A44528-DB36-4F8C-9869-CF35F0FB3EAC}" dt="2026-09-08T09:00:06.973" v="5" actId="1076"/>
+          <ac:spMkLst>
+            <pc:docMk/>
+            <pc:sldMk cId="0" sldId="261"/>
+            <ac:spMk id="5" creationId="{00000000-0000-0000-0000-000000000000}"/>
+          </ac:spMkLst>
+        </pc:spChg>
+        <pc:spChg chg="mod">
+          <ac:chgData name="Jess W" userId="0a9e92bfc7a9bd4f" providerId="LiveId" clId="{44A44528-DB36-4F8C-9869-CF35F0FB3EAC}" dt="2026-09-08T10:16:27.213" v="227" actId="123"/>
+          <ac:spMkLst>
+            <pc:docMk/>
+            <pc:sldMk cId="0" sldId="261"/>
+            <ac:spMk id="7" creationId="{00000000-0000-0000-0000-000000000000}"/>
+          </ac:spMkLst>
+        </pc:spChg>
+        <pc:spChg chg="del">
+          <ac:chgData name="Jess W" userId="0a9e92bfc7a9bd4f" providerId="LiveId" clId="{44A44528-DB36-4F8C-9869-CF35F0FB3EAC}" dt="2026-09-08T09:01:11.786" v="9" actId="478"/>
           <ac:spMkLst>
             <pc:docMk/>
             <pc:sldMk cId="0" sldId="261"/>
             <ac:spMk id="8" creationId="{00000000-0000-0000-0000-000000000000}"/>
           </ac:spMkLst>
         </pc:spChg>
+        <pc:picChg chg="mod">
+          <ac:chgData name="Jess W" userId="0a9e92bfc7a9bd4f" providerId="LiveId" clId="{44A44528-DB36-4F8C-9869-CF35F0FB3EAC}" dt="2026-09-08T09:02:21.835" v="15" actId="1076"/>
+          <ac:picMkLst>
+            <pc:docMk/>
+            <pc:sldMk cId="0" sldId="261"/>
+            <ac:picMk id="6" creationId="{00000000-0000-0000-0000-000000000000}"/>
+          </ac:picMkLst>
+        </pc:picChg>
       </pc:sldChg>
-      <pc:sldChg chg="modSp mod">
-        <pc:chgData name="Jess W" userId="0a9e92bfc7a9bd4f" providerId="LiveId" clId="{44A44528-DB36-4F8C-9869-CF35F0FB3EAC}" dt="2026-09-04T19:43:04.010" v="11" actId="20577"/>
+      <pc:sldChg chg="delSp modSp mod">
+        <pc:chgData name="Jess W" userId="0a9e92bfc7a9bd4f" providerId="LiveId" clId="{44A44528-DB36-4F8C-9869-CF35F0FB3EAC}" dt="2026-09-08T10:16:55.126" v="230" actId="207"/>
         <pc:sldMkLst>
           <pc:docMk/>
           <pc:sldMk cId="0" sldId="262"/>
         </pc:sldMkLst>
         <pc:spChg chg="mod">
-          <ac:chgData name="Jess W" userId="0a9e92bfc7a9bd4f" providerId="LiveId" clId="{44A44528-DB36-4F8C-9869-CF35F0FB3EAC}" dt="2026-09-04T19:43:04.010" v="11" actId="20577"/>
+          <ac:chgData name="Jess W" userId="0a9e92bfc7a9bd4f" providerId="LiveId" clId="{44A44528-DB36-4F8C-9869-CF35F0FB3EAC}" dt="2026-09-08T09:02:13.137" v="14" actId="1076"/>
+          <ac:spMkLst>
+            <pc:docMk/>
+            <pc:sldMk cId="0" sldId="262"/>
+            <ac:spMk id="5" creationId="{00000000-0000-0000-0000-000000000000}"/>
+          </ac:spMkLst>
+        </pc:spChg>
+        <pc:spChg chg="mod">
+          <ac:chgData name="Jess W" userId="0a9e92bfc7a9bd4f" providerId="LiveId" clId="{44A44528-DB36-4F8C-9869-CF35F0FB3EAC}" dt="2026-09-08T10:16:55.126" v="230" actId="207"/>
+          <ac:spMkLst>
+            <pc:docMk/>
+            <pc:sldMk cId="0" sldId="262"/>
+            <ac:spMk id="7" creationId="{00000000-0000-0000-0000-000000000000}"/>
+          </ac:spMkLst>
+        </pc:spChg>
+        <pc:spChg chg="del">
+          <ac:chgData name="Jess W" userId="0a9e92bfc7a9bd4f" providerId="LiveId" clId="{44A44528-DB36-4F8C-9869-CF35F0FB3EAC}" dt="2026-09-08T09:01:46.702" v="10" actId="478"/>
           <ac:spMkLst>
             <pc:docMk/>
             <pc:sldMk cId="0" sldId="262"/>
@@ -255,43 +414,74 @@
           </ac:spMkLst>
         </pc:spChg>
       </pc:sldChg>
-      <pc:sldChg chg="modSp mod">
-        <pc:chgData name="Jess W" userId="0a9e92bfc7a9bd4f" providerId="LiveId" clId="{44A44528-DB36-4F8C-9869-CF35F0FB3EAC}" dt="2026-09-04T19:41:38.795" v="7" actId="20577"/>
+      <pc:sldChg chg="delSp modSp mod">
+        <pc:chgData name="Jess W" userId="0a9e92bfc7a9bd4f" providerId="LiveId" clId="{44A44528-DB36-4F8C-9869-CF35F0FB3EAC}" dt="2026-09-08T19:34:57.213" v="604" actId="6549"/>
         <pc:sldMkLst>
           <pc:docMk/>
           <pc:sldMk cId="0" sldId="263"/>
         </pc:sldMkLst>
         <pc:spChg chg="mod">
-          <ac:chgData name="Jess W" userId="0a9e92bfc7a9bd4f" providerId="LiveId" clId="{44A44528-DB36-4F8C-9869-CF35F0FB3EAC}" dt="2026-09-04T19:41:38.795" v="7" actId="20577"/>
+          <ac:chgData name="Jess W" userId="0a9e92bfc7a9bd4f" providerId="LiveId" clId="{44A44528-DB36-4F8C-9869-CF35F0FB3EAC}" dt="2026-09-08T09:02:00.213" v="12" actId="1076"/>
           <ac:spMkLst>
             <pc:docMk/>
             <pc:sldMk cId="0" sldId="263"/>
-            <ac:spMk id="9" creationId="{00000000-0000-0000-0000-000000000000}"/>
+            <ac:spMk id="4" creationId="{00000000-0000-0000-0000-000000000000}"/>
           </ac:spMkLst>
         </pc:spChg>
         <pc:spChg chg="mod">
-          <ac:chgData name="Jess W" userId="0a9e92bfc7a9bd4f" providerId="LiveId" clId="{44A44528-DB36-4F8C-9869-CF35F0FB3EAC}" dt="2026-09-04T19:40:43.410" v="3" actId="6549"/>
+          <ac:chgData name="Jess W" userId="0a9e92bfc7a9bd4f" providerId="LiveId" clId="{44A44528-DB36-4F8C-9869-CF35F0FB3EAC}" dt="2026-09-08T09:02:03.933" v="13" actId="1076"/>
+          <ac:spMkLst>
+            <pc:docMk/>
+            <pc:sldMk cId="0" sldId="263"/>
+            <ac:spMk id="5" creationId="{00000000-0000-0000-0000-000000000000}"/>
+          </ac:spMkLst>
+        </pc:spChg>
+        <pc:spChg chg="mod">
+          <ac:chgData name="Jess W" userId="0a9e92bfc7a9bd4f" providerId="LiveId" clId="{44A44528-DB36-4F8C-9869-CF35F0FB3EAC}" dt="2026-09-08T19:34:57.213" v="604" actId="6549"/>
           <ac:spMkLst>
             <pc:docMk/>
             <pc:sldMk cId="0" sldId="263"/>
             <ac:spMk id="12" creationId="{00000000-0000-0000-0000-000000000000}"/>
           </ac:spMkLst>
         </pc:spChg>
+        <pc:spChg chg="del">
+          <ac:chgData name="Jess W" userId="0a9e92bfc7a9bd4f" providerId="LiveId" clId="{44A44528-DB36-4F8C-9869-CF35F0FB3EAC}" dt="2026-09-08T09:01:51.859" v="11" actId="478"/>
+          <ac:spMkLst>
+            <pc:docMk/>
+            <pc:sldMk cId="0" sldId="263"/>
+            <ac:spMk id="43" creationId="{00000000-0000-0000-0000-000000000000}"/>
+          </ac:spMkLst>
+        </pc:spChg>
       </pc:sldChg>
       <pc:sldChg chg="modSp mod">
-        <pc:chgData name="Jess W" userId="0a9e92bfc7a9bd4f" providerId="LiveId" clId="{44A44528-DB36-4F8C-9869-CF35F0FB3EAC}" dt="2026-09-04T19:43:50.354" v="15" actId="20577"/>
+        <pc:chgData name="Jess W" userId="0a9e92bfc7a9bd4f" providerId="LiveId" clId="{44A44528-DB36-4F8C-9869-CF35F0FB3EAC}" dt="2026-09-08T19:51:01.266" v="663" actId="1076"/>
         <pc:sldMkLst>
           <pc:docMk/>
-          <pc:sldMk cId="0" sldId="265"/>
+          <pc:sldMk cId="0" sldId="264"/>
         </pc:sldMkLst>
         <pc:spChg chg="mod">
-          <ac:chgData name="Jess W" userId="0a9e92bfc7a9bd4f" providerId="LiveId" clId="{44A44528-DB36-4F8C-9869-CF35F0FB3EAC}" dt="2026-09-04T19:43:50.354" v="15" actId="20577"/>
+          <ac:chgData name="Jess W" userId="0a9e92bfc7a9bd4f" providerId="LiveId" clId="{44A44528-DB36-4F8C-9869-CF35F0FB3EAC}" dt="2026-09-08T19:51:01.266" v="663" actId="1076"/>
           <ac:spMkLst>
             <pc:docMk/>
-            <pc:sldMk cId="0" sldId="265"/>
+            <pc:sldMk cId="0" sldId="264"/>
+            <ac:spMk id="6" creationId="{00000000-0000-0000-0000-000000000000}"/>
+          </ac:spMkLst>
+        </pc:spChg>
+        <pc:spChg chg="mod">
+          <ac:chgData name="Jess W" userId="0a9e92bfc7a9bd4f" providerId="LiveId" clId="{44A44528-DB36-4F8C-9869-CF35F0FB3EAC}" dt="2026-09-08T19:49:29.251" v="647" actId="1076"/>
+          <ac:spMkLst>
+            <pc:docMk/>
+            <pc:sldMk cId="0" sldId="264"/>
             <ac:spMk id="7" creationId="{00000000-0000-0000-0000-000000000000}"/>
           </ac:spMkLst>
         </pc:spChg>
+      </pc:sldChg>
+      <pc:sldChg chg="new del">
+        <pc:chgData name="Jess W" userId="0a9e92bfc7a9bd4f" providerId="LiveId" clId="{44A44528-DB36-4F8C-9869-CF35F0FB3EAC}" dt="2026-09-08T17:54:57.417" v="588" actId="680"/>
+        <pc:sldMkLst>
+          <pc:docMk/>
+          <pc:sldMk cId="3137206392" sldId="266"/>
+        </pc:sldMkLst>
       </pc:sldChg>
     </pc:docChg>
   </pc:docChgLst>
@@ -477,7 +667,7 @@
           <a:p>
             <a:fld id="{5BCAD085-E8A6-8845-BD4E-CB4CCA059FC4}" type="datetimeFigureOut">
               <a:rPr lang="en-US" smtClean="0"/>
-              <a:t>9/4/2026</a:t>
+              <a:t>9/8/2026</a:t>
             </a:fld>
             <a:endParaRPr lang="en-US"/>
           </a:p>
@@ -645,7 +835,7 @@
           <a:p>
             <a:fld id="{5BCAD085-E8A6-8845-BD4E-CB4CCA059FC4}" type="datetimeFigureOut">
               <a:rPr lang="en-US" smtClean="0"/>
-              <a:t>9/4/2026</a:t>
+              <a:t>9/8/2026</a:t>
             </a:fld>
             <a:endParaRPr lang="en-US"/>
           </a:p>
@@ -823,7 +1013,7 @@
           <a:p>
             <a:fld id="{5BCAD085-E8A6-8845-BD4E-CB4CCA059FC4}" type="datetimeFigureOut">
               <a:rPr lang="en-US" smtClean="0"/>
-              <a:t>9/4/2026</a:t>
+              <a:t>9/8/2026</a:t>
             </a:fld>
             <a:endParaRPr lang="en-US"/>
           </a:p>
@@ -991,7 +1181,7 @@
           <a:p>
             <a:fld id="{5BCAD085-E8A6-8845-BD4E-CB4CCA059FC4}" type="datetimeFigureOut">
               <a:rPr lang="en-US" smtClean="0"/>
-              <a:t>9/4/2026</a:t>
+              <a:t>9/8/2026</a:t>
             </a:fld>
             <a:endParaRPr lang="en-US"/>
           </a:p>
@@ -1236,7 +1426,7 @@
           <a:p>
             <a:fld id="{5BCAD085-E8A6-8845-BD4E-CB4CCA059FC4}" type="datetimeFigureOut">
               <a:rPr lang="en-US" smtClean="0"/>
-              <a:t>9/4/2026</a:t>
+              <a:t>9/8/2026</a:t>
             </a:fld>
             <a:endParaRPr lang="en-US"/>
           </a:p>
@@ -1521,7 +1711,7 @@
           <a:p>
             <a:fld id="{5BCAD085-E8A6-8845-BD4E-CB4CCA059FC4}" type="datetimeFigureOut">
               <a:rPr lang="en-US" smtClean="0"/>
-              <a:t>9/4/2026</a:t>
+              <a:t>9/8/2026</a:t>
             </a:fld>
             <a:endParaRPr lang="en-US"/>
           </a:p>
@@ -1940,7 +2130,7 @@
           <a:p>
             <a:fld id="{5BCAD085-E8A6-8845-BD4E-CB4CCA059FC4}" type="datetimeFigureOut">
               <a:rPr lang="en-US" smtClean="0"/>
-              <a:t>9/4/2026</a:t>
+              <a:t>9/8/2026</a:t>
             </a:fld>
             <a:endParaRPr lang="en-US"/>
           </a:p>
@@ -2057,7 +2247,7 @@
           <a:p>
             <a:fld id="{5BCAD085-E8A6-8845-BD4E-CB4CCA059FC4}" type="datetimeFigureOut">
               <a:rPr lang="en-US" smtClean="0"/>
-              <a:t>9/4/2026</a:t>
+              <a:t>9/8/2026</a:t>
             </a:fld>
             <a:endParaRPr lang="en-US"/>
           </a:p>
@@ -2152,7 +2342,7 @@
           <a:p>
             <a:fld id="{5BCAD085-E8A6-8845-BD4E-CB4CCA059FC4}" type="datetimeFigureOut">
               <a:rPr lang="en-US" smtClean="0"/>
-              <a:t>9/4/2026</a:t>
+              <a:t>9/8/2026</a:t>
             </a:fld>
             <a:endParaRPr lang="en-US"/>
           </a:p>
@@ -2427,7 +2617,7 @@
           <a:p>
             <a:fld id="{5BCAD085-E8A6-8845-BD4E-CB4CCA059FC4}" type="datetimeFigureOut">
               <a:rPr lang="en-US" smtClean="0"/>
-              <a:t>9/4/2026</a:t>
+              <a:t>9/8/2026</a:t>
             </a:fld>
             <a:endParaRPr lang="en-US"/>
           </a:p>
@@ -2679,7 +2869,7 @@
           <a:p>
             <a:fld id="{5BCAD085-E8A6-8845-BD4E-CB4CCA059FC4}" type="datetimeFigureOut">
               <a:rPr lang="en-US" smtClean="0"/>
-              <a:t>9/4/2026</a:t>
+              <a:t>9/8/2026</a:t>
             </a:fld>
             <a:endParaRPr lang="en-US"/>
           </a:p>
@@ -2890,7 +3080,7 @@
           <a:p>
             <a:fld id="{5BCAD085-E8A6-8845-BD4E-CB4CCA059FC4}" type="datetimeFigureOut">
               <a:rPr lang="en-US" smtClean="0"/>
-              <a:t>9/4/2026</a:t>
+              <a:t>9/8/2026</a:t>
             </a:fld>
             <a:endParaRPr lang="en-US"/>
           </a:p>
@@ -3369,8 +3559,8 @@
         </p:nvSpPr>
         <p:spPr>
           <a:xfrm>
-            <a:off x="1371600" y="1188720"/>
-            <a:ext cx="9144000" cy="914400"/>
+            <a:off x="4468451" y="1380744"/>
+            <a:ext cx="3571698" cy="914400"/>
           </a:xfrm>
           <a:prstGeom prst="rect">
             <a:avLst/>
@@ -3383,7 +3573,7 @@
           </a:bodyPr>
           <a:lstStyle/>
           <a:p>
-            <a:pPr algn="ctr">
+            <a:pPr algn="l">
               <a:defRPr sz="5200" b="1">
                 <a:solidFill>
                   <a:srgbClr val="FFFFFF"/>
@@ -3392,6 +3582,7 @@
               </a:defRPr>
             </a:pPr>
             <a:r>
+              <a:rPr dirty="0"/>
               <a:t>ElimuMatch</a:t>
             </a:r>
           </a:p>
@@ -3465,16 +3656,21 @@
             </a:pPr>
             <a:r>
               <a:rPr dirty="0"/>
-              <a:t>A data-driven platform for fee support to </a:t>
+              <a:t>A data-driven platform for fee support to secondary </a:t>
             </a:r>
             <a:r>
               <a:rPr lang="en-GB" dirty="0"/>
-              <a:t>secondary school students in </a:t>
+              <a:t>school </a:t>
             </a:r>
             <a:r>
               <a:rPr dirty="0"/>
-              <a:t>Kenya</a:t>
-            </a:r>
+              <a:t>students</a:t>
+            </a:r>
+            <a:r>
+              <a:rPr lang="en-GB" dirty="0"/>
+              <a:t> in Kenya</a:t>
+            </a:r>
+            <a:endParaRPr dirty="0"/>
           </a:p>
         </p:txBody>
       </p:sp>
@@ -3523,7 +3719,7 @@
         </p:nvSpPr>
         <p:spPr>
           <a:xfrm>
-            <a:off x="1371600" y="5361503"/>
+            <a:off x="1371600" y="5332511"/>
             <a:ext cx="9144000" cy="307777"/>
           </a:xfrm>
           <a:prstGeom prst="rect">
@@ -3568,7 +3764,7 @@
         </p:nvSpPr>
         <p:spPr>
           <a:xfrm>
-            <a:off x="1371600" y="5852160"/>
+            <a:off x="1371600" y="5911449"/>
             <a:ext cx="9144000" cy="365760"/>
           </a:xfrm>
           <a:prstGeom prst="rect">
@@ -3602,6 +3798,30 @@
           </a:p>
         </p:txBody>
       </p:sp>
+      <p:pic>
+        <p:nvPicPr>
+          <p:cNvPr id="11" name="Picture 10" descr="elimumatch_logo_gold.png"/>
+          <p:cNvPicPr>
+            <a:picLocks noChangeAspect="1"/>
+          </p:cNvPicPr>
+          <p:nvPr/>
+        </p:nvPicPr>
+        <p:blipFill>
+          <a:blip r:embed="rId2"/>
+          <a:stretch>
+            <a:fillRect/>
+          </a:stretch>
+        </p:blipFill>
+        <p:spPr>
+          <a:xfrm>
+            <a:off x="3984171" y="1572768"/>
+            <a:ext cx="484280" cy="576072"/>
+          </a:xfrm>
+          <a:prstGeom prst="rect">
+            <a:avLst/>
+          </a:prstGeom>
+        </p:spPr>
+      </p:pic>
     </p:spTree>
   </p:cSld>
   <p:clrMapOvr>
@@ -4064,7 +4284,7 @@
         <p:spPr>
           <a:xfrm>
             <a:off x="6400800" y="1188720"/>
-            <a:ext cx="5029200" cy="2369880"/>
+            <a:ext cx="5029200" cy="5029200"/>
           </a:xfrm>
           <a:prstGeom prst="rect">
             <a:avLst/>
@@ -4086,7 +4306,6 @@
               </a:defRPr>
             </a:pPr>
             <a:r>
-              <a:rPr dirty="0"/>
               <a:t>Figure sources:</a:t>
             </a:r>
           </a:p>
@@ -4103,7 +4322,6 @@
               </a:defRPr>
             </a:pPr>
             <a:r>
-              <a:rPr dirty="0"/>
               <a:t>Slide 2: Author charts from UNESCO IICBA (2025) and KNBS (2025)</a:t>
             </a:r>
           </a:p>
@@ -4120,7 +4338,6 @@
               </a:defRPr>
             </a:pPr>
             <a:r>
-              <a:rPr dirty="0"/>
               <a:t>Slide 3: Illustrative positioning map (author)</a:t>
             </a:r>
           </a:p>
@@ -4137,7 +4354,6 @@
               </a:defRPr>
             </a:pPr>
             <a:r>
-              <a:rPr dirty="0"/>
               <a:t>Slide 4: Product layer diagram (author)</a:t>
             </a:r>
           </a:p>
@@ -4154,7 +4370,6 @@
               </a:defRPr>
             </a:pPr>
             <a:r>
-              <a:rPr dirty="0"/>
               <a:t>Slide 5: Gift journey and operations flow (author)</a:t>
             </a:r>
           </a:p>
@@ -4171,7 +4386,6 @@
               </a:defRPr>
             </a:pPr>
             <a:r>
-              <a:rPr dirty="0"/>
               <a:t>Slide 6: Model comparison from project pipeline on test data</a:t>
             </a:r>
           </a:p>
@@ -4188,7 +4402,6 @@
               </a:defRPr>
             </a:pPr>
             <a:r>
-              <a:rPr dirty="0"/>
               <a:t>Slide 7: Year-1 economics chart (illustrative, author)</a:t>
             </a:r>
           </a:p>
@@ -4204,7 +4417,7 @@
                 <a:latin typeface="Calibri"/>
               </a:defRPr>
             </a:pPr>
-            <a:endParaRPr dirty="0"/>
+            <a:endParaRPr/>
           </a:p>
           <a:p>
             <a:pPr algn="l">
@@ -4219,7 +4432,6 @@
               </a:defRPr>
             </a:pPr>
             <a:r>
-              <a:rPr dirty="0"/>
               <a:t>All results are from proof-of-concept data (1,000 students). Not yet validated on live school records.</a:t>
             </a:r>
           </a:p>
@@ -4426,8 +4638,8 @@
         </p:nvSpPr>
         <p:spPr>
           <a:xfrm>
-            <a:off x="640080" y="640080"/>
-            <a:ext cx="10972800" cy="830997"/>
+            <a:off x="640080" y="564029"/>
+            <a:ext cx="10972800" cy="731520"/>
           </a:xfrm>
           <a:prstGeom prst="rect">
             <a:avLst/>
@@ -4450,15 +4662,7 @@
             </a:pPr>
             <a:r>
               <a:rPr dirty="0"/>
-              <a:t>Kenya</a:t>
-            </a:r>
-            <a:r>
-              <a:rPr lang="en-GB" dirty="0"/>
-              <a:t> has</a:t>
-            </a:r>
-            <a:r>
-              <a:rPr dirty="0"/>
-              <a:t> expanded access, but nearly half of students still do not finish secondary school</a:t>
+              <a:t>Kenya expanded access, but nearly half of students still do not finish secondary school</a:t>
             </a:r>
           </a:p>
         </p:txBody>
@@ -4480,7 +4684,7 @@
         <p:spPr>
           <a:xfrm>
             <a:off x="640080" y="1554480"/>
-            <a:ext cx="5029200" cy="2745366"/>
+            <a:ext cx="5029200" cy="2664381"/>
           </a:xfrm>
           <a:prstGeom prst="rect">
             <a:avLst/>
@@ -4504,7 +4708,7 @@
         <p:spPr>
           <a:xfrm>
             <a:off x="6217920" y="1554480"/>
-            <a:ext cx="5029200" cy="2757852"/>
+            <a:ext cx="5029200" cy="2581507"/>
           </a:xfrm>
           <a:prstGeom prst="rect">
             <a:avLst/>
@@ -4542,6 +4746,7 @@
               </a:defRPr>
             </a:pPr>
             <a:r>
+              <a:rPr dirty="0"/>
               <a:t>4.32 million students were enrolled by 2024, all vulnerable to fee pressure and income shocks.</a:t>
             </a:r>
           </a:p>
@@ -4558,6 +4763,7 @@
               </a:defRPr>
             </a:pPr>
             <a:r>
+              <a:rPr dirty="0"/>
               <a:t>People want to help, but support follows personal connections instead of reaching those who need it most.</a:t>
             </a:r>
           </a:p>
@@ -4571,8 +4777,8 @@
         </p:nvSpPr>
         <p:spPr>
           <a:xfrm>
-            <a:off x="640080" y="6400800"/>
-            <a:ext cx="10972800" cy="365760"/>
+            <a:off x="640080" y="6355080"/>
+            <a:ext cx="10972800" cy="411480"/>
           </a:xfrm>
           <a:prstGeom prst="rect">
             <a:avLst/>
@@ -4586,9 +4792,9 @@
           <a:lstStyle/>
           <a:p>
             <a:pPr algn="l">
-              <a:defRPr sz="1000" b="0">
-                <a:solidFill>
-                  <a:srgbClr val="5C6B73"/>
+              <a:defRPr sz="1200" b="0">
+                <a:solidFill>
+                  <a:srgbClr val="14213D"/>
                 </a:solidFill>
                 <a:latin typeface="Calibri"/>
               </a:defRPr>
@@ -4764,7 +4970,7 @@
         </p:nvSpPr>
         <p:spPr>
           <a:xfrm>
-            <a:off x="640080" y="640080"/>
+            <a:off x="640080" y="566928"/>
             <a:ext cx="10972800" cy="731520"/>
           </a:xfrm>
           <a:prstGeom prst="rect">
@@ -4787,6 +4993,7 @@
               </a:defRPr>
             </a:pPr>
             <a:r>
+              <a:rPr dirty="0"/>
               <a:t>NGO help often focuses on ASAL, while students elsewhere also face fee pressure and dropout risk</a:t>
             </a:r>
           </a:p>
@@ -4809,7 +5016,7 @@
         <p:spPr>
           <a:xfrm>
             <a:off x="640080" y="1554480"/>
-            <a:ext cx="5303520" cy="4011783"/>
+            <a:ext cx="5303520" cy="3984524"/>
           </a:xfrm>
           <a:prstGeom prst="rect">
             <a:avLst/>
@@ -4824,8 +5031,8 @@
         </p:nvSpPr>
         <p:spPr>
           <a:xfrm>
-            <a:off x="6400800" y="1554480"/>
-            <a:ext cx="5029200" cy="4114800"/>
+            <a:off x="6248402" y="1554511"/>
+            <a:ext cx="5303518" cy="3862596"/>
           </a:xfrm>
           <a:prstGeom prst="rect">
             <a:avLst/>
@@ -4838,7 +5045,7 @@
           </a:bodyPr>
           <a:lstStyle/>
           <a:p>
-            <a:pPr algn="l">
+            <a:pPr algn="just">
               <a:defRPr sz="1600" b="1">
                 <a:solidFill>
                   <a:srgbClr val="14213D"/>
@@ -4848,11 +5055,11 @@
             </a:pPr>
             <a:r>
               <a:rPr dirty="0"/>
-              <a:t>How support is directed today:</a:t>
-            </a:r>
-          </a:p>
-          <a:p>
-            <a:pPr algn="l">
+              <a:t>How support is directed today</a:t>
+            </a:r>
+          </a:p>
+          <a:p>
+            <a:pPr algn="just">
               <a:spcBef>
                 <a:spcPts val="600"/>
               </a:spcBef>
@@ -4864,12 +5071,16 @@
               </a:defRPr>
             </a:pPr>
             <a:r>
-              <a:rPr dirty="0"/>
-              <a:t>•  Many NGO programs concentrate on arid and semi-arid lands (ASAL), while students elsewhere also face fee pressure and dropout risk.</a:t>
-            </a:r>
-          </a:p>
-          <a:p>
-            <a:pPr algn="l">
+              <a:rPr lang="en-GB" b="1" dirty="0"/>
+              <a:t>Geographic concentration: </a:t>
+            </a:r>
+            <a:r>
+              <a:rPr lang="en-GB" dirty="0"/>
+              <a:t>Many NGO programs focus on arid and semi-arid lands (ASAL), while students elsewhere also face fee pressure.</a:t>
+            </a:r>
+          </a:p>
+          <a:p>
+            <a:pPr algn="just">
               <a:spcBef>
                 <a:spcPts val="600"/>
               </a:spcBef>
@@ -4881,12 +5092,16 @@
               </a:defRPr>
             </a:pPr>
             <a:r>
-              <a:rPr dirty="0"/>
-              <a:t>•  Most individual donors rely on personal contacts, so students without connections are overlooked.</a:t>
-            </a:r>
-          </a:p>
-          <a:p>
-            <a:pPr algn="l">
+              <a:rPr lang="en-GB" b="1" dirty="0"/>
+              <a:t>Network reliance: </a:t>
+            </a:r>
+            <a:r>
+              <a:rPr lang="en-GB" dirty="0"/>
+              <a:t>Individual helpers often rely on personal contacts, so students without connections are overlooked.</a:t>
+            </a:r>
+          </a:p>
+          <a:p>
+            <a:pPr algn="just">
               <a:spcBef>
                 <a:spcPts val="600"/>
               </a:spcBef>
@@ -4898,12 +5113,16 @@
               </a:defRPr>
             </a:pPr>
             <a:r>
-              <a:rPr dirty="0"/>
-              <a:t>•  Bursary contests run once a year with heavy paperwork, leaving gaps the rest of the time.</a:t>
-            </a:r>
-          </a:p>
-          <a:p>
-            <a:pPr algn="l">
+              <a:rPr lang="en-GB" b="1" dirty="0"/>
+              <a:t>Bursary friction: </a:t>
+            </a:r>
+            <a:r>
+              <a:rPr lang="en-GB" dirty="0"/>
+              <a:t>Annual contests bring heavy paperwork and long gaps the rest of the year.</a:t>
+            </a:r>
+          </a:p>
+          <a:p>
+            <a:pPr algn="just">
               <a:spcBef>
                 <a:spcPts val="600"/>
               </a:spcBef>
@@ -4915,12 +5134,16 @@
               </a:defRPr>
             </a:pPr>
             <a:r>
-              <a:rPr dirty="0"/>
-              <a:t>•  Crowdfunding and school lists rarely rank who is most at risk of leaving.</a:t>
-            </a:r>
-          </a:p>
-          <a:p>
-            <a:pPr algn="l">
+              <a:rPr lang="en-GB" b="1" dirty="0"/>
+              <a:t>Unranked dropout risk: </a:t>
+            </a:r>
+            <a:r>
+              <a:rPr lang="en-GB" dirty="0"/>
+              <a:t>Crowdfunding and school lists rarely prioritize who is most at risk of leaving.</a:t>
+            </a:r>
+          </a:p>
+          <a:p>
+            <a:pPr algn="just">
               <a:spcBef>
                 <a:spcPts val="600"/>
               </a:spcBef>
@@ -4934,24 +5157,56 @@
             <a:endParaRPr dirty="0"/>
           </a:p>
           <a:p>
-            <a:pPr algn="l">
+            <a:pPr algn="just">
               <a:spcBef>
                 <a:spcPts val="600"/>
               </a:spcBef>
-              <a:defRPr sz="1500" b="1">
+              <a:defRPr sz="1400" b="0">
+                <a:solidFill>
+                  <a:srgbClr val="14213D"/>
+                </a:solidFill>
+                <a:latin typeface="Calibri"/>
+              </a:defRPr>
+            </a:pPr>
+            <a:r>
+              <a:rPr lang="en-GB" sz="1600" b="1" dirty="0" err="1">
                 <a:solidFill>
                   <a:srgbClr val="1B7A5A"/>
                 </a:solidFill>
                 <a:latin typeface="Calibri"/>
-              </a:defRPr>
-            </a:pPr>
-            <a:r>
-              <a:rPr dirty="0" err="1"/>
+              </a:rPr>
               <a:t>ElimuMatch</a:t>
             </a:r>
             <a:r>
-              <a:rPr dirty="0"/>
-              <a:t> covers all 47 counties: donors can choose any place, and priority follows measured risk, not geography alone.</a:t>
+              <a:rPr lang="en-GB" sz="1600" b="1" dirty="0">
+                <a:solidFill>
+                  <a:srgbClr val="1B7A5A"/>
+                </a:solidFill>
+                <a:latin typeface="Calibri"/>
+              </a:rPr>
+              <a:t> closes these gaps</a:t>
+            </a:r>
+          </a:p>
+          <a:p>
+            <a:pPr algn="just">
+              <a:spcBef>
+                <a:spcPts val="600"/>
+              </a:spcBef>
+              <a:defRPr sz="1400" b="0">
+                <a:solidFill>
+                  <a:srgbClr val="14213D"/>
+                </a:solidFill>
+                <a:latin typeface="Calibri"/>
+              </a:defRPr>
+            </a:pPr>
+            <a:r>
+              <a:rPr lang="en-GB" sz="1400" dirty="0">
+                <a:solidFill>
+                  <a:srgbClr val="1B7A5A"/>
+                </a:solidFill>
+                <a:latin typeface="Calibri"/>
+              </a:rPr>
+              <a:t>Helpers can give in any of Kenya’s 47 counties, to students prioritized by measured dropout risk, through a simple path that settles straight to the school.</a:t>
             </a:r>
           </a:p>
         </p:txBody>
@@ -5085,7 +5340,7 @@
         </p:nvSpPr>
         <p:spPr>
           <a:xfrm>
-            <a:off x="640080" y="201168"/>
+            <a:off x="457200" y="261475"/>
             <a:ext cx="10972800" cy="365760"/>
           </a:xfrm>
           <a:prstGeom prst="rect">
@@ -5108,6 +5363,7 @@
               </a:defRPr>
             </a:pPr>
             <a:r>
+              <a:rPr dirty="0"/>
               <a:t>OUR SOLUTION</a:t>
             </a:r>
           </a:p>
@@ -5121,7 +5377,7 @@
         </p:nvSpPr>
         <p:spPr>
           <a:xfrm>
-            <a:off x="640080" y="640080"/>
+            <a:off x="457200" y="627235"/>
             <a:ext cx="10972800" cy="731520"/>
           </a:xfrm>
           <a:prstGeom prst="rect">
@@ -5144,7 +5400,12 @@
               </a:defRPr>
             </a:pPr>
             <a:r>
-              <a:t>ElimuMatch identifies at-risk students and lets donors support them in four simple steps</a:t>
+              <a:rPr dirty="0" err="1"/>
+              <a:t>ElimuMatch</a:t>
+            </a:r>
+            <a:r>
+              <a:rPr dirty="0"/>
+              <a:t> identifies at-risk students and lets helpers support them in four simple steps</a:t>
             </a:r>
           </a:p>
         </p:txBody>
@@ -5165,8 +5426,8 @@
         </p:blipFill>
         <p:spPr>
           <a:xfrm>
-            <a:off x="457200" y="1463040"/>
-            <a:ext cx="5486400" cy="3070673"/>
+            <a:off x="457200" y="1417320"/>
+            <a:ext cx="5486400" cy="3982330"/>
           </a:xfrm>
           <a:prstGeom prst="rect">
             <a:avLst/>
@@ -5181,8 +5442,8 @@
         </p:nvSpPr>
         <p:spPr>
           <a:xfrm>
-            <a:off x="6400800" y="1463040"/>
-            <a:ext cx="5029200" cy="3657600"/>
+            <a:off x="6705600" y="1846519"/>
+            <a:ext cx="5029200" cy="3303468"/>
           </a:xfrm>
           <a:prstGeom prst="rect">
             <a:avLst/>
@@ -5204,13 +5465,14 @@
               </a:defRPr>
             </a:pPr>
             <a:r>
-              <a:t>What donors experience:</a:t>
+              <a:rPr dirty="0"/>
+              <a:t>What helpers experience</a:t>
             </a:r>
           </a:p>
           <a:p>
             <a:pPr algn="l">
               <a:spcBef>
-                <a:spcPts val="600"/>
+                <a:spcPts val="1400"/>
               </a:spcBef>
               <a:defRPr sz="1500" b="0">
                 <a:solidFill>
@@ -5220,73 +5482,66 @@
               </a:defRPr>
             </a:pPr>
             <a:r>
+              <a:rPr dirty="0"/>
               <a:t>They pick a county, choose a school, see a student's fee balance, give, and get a receipt.</a:t>
             </a:r>
           </a:p>
           <a:p>
             <a:pPr algn="l">
               <a:spcBef>
-                <a:spcPts val="600"/>
+                <a:spcPts val="2200"/>
               </a:spcBef>
-              <a:defRPr sz="800" b="0">
+              <a:defRPr sz="1600" b="1">
+                <a:solidFill>
+                  <a:srgbClr val="1B7A5A"/>
+                </a:solidFill>
+                <a:latin typeface="Calibri"/>
+              </a:defRPr>
+            </a:pPr>
+            <a:r>
+              <a:rPr dirty="0"/>
+              <a:t>What happens behind the scenes</a:t>
+            </a:r>
+          </a:p>
+          <a:p>
+            <a:pPr algn="just">
+              <a:spcBef>
+                <a:spcPts val="1400"/>
+              </a:spcBef>
+              <a:defRPr sz="1500" b="0">
                 <a:solidFill>
                   <a:srgbClr val="14213D"/>
                 </a:solidFill>
                 <a:latin typeface="Calibri"/>
               </a:defRPr>
             </a:pPr>
-            <a:endParaRPr/>
+            <a:r>
+              <a:rPr dirty="0"/>
+              <a:t>Our system scores each student's risk of dropping out. Only students who need fee help appear. </a:t>
+            </a:r>
+            <a:endParaRPr lang="en-GB" dirty="0"/>
+          </a:p>
+          <a:p>
+            <a:pPr algn="just">
+              <a:spcBef>
+                <a:spcPts val="1400"/>
+              </a:spcBef>
+              <a:defRPr sz="1500" b="0">
+                <a:solidFill>
+                  <a:srgbClr val="14213D"/>
+                </a:solidFill>
+                <a:latin typeface="Calibri"/>
+              </a:defRPr>
+            </a:pPr>
+            <a:r>
+              <a:rPr dirty="0"/>
+              <a:t>School staff can see the reasons behind each score.</a:t>
+            </a:r>
           </a:p>
           <a:p>
             <a:pPr algn="l">
               <a:spcBef>
-                <a:spcPts val="600"/>
-              </a:spcBef>
-              <a:defRPr sz="1600" b="1">
-                <a:solidFill>
-                  <a:srgbClr val="1B7A5A"/>
-                </a:solidFill>
-                <a:latin typeface="Calibri"/>
-              </a:defRPr>
-            </a:pPr>
-            <a:r>
-              <a:t>What happens behind the scenes:</a:t>
-            </a:r>
-          </a:p>
-          <a:p>
-            <a:pPr algn="l">
-              <a:spcBef>
-                <a:spcPts val="600"/>
-              </a:spcBef>
-              <a:defRPr sz="1500" b="0">
-                <a:solidFill>
-                  <a:srgbClr val="14213D"/>
-                </a:solidFill>
-                <a:latin typeface="Calibri"/>
-              </a:defRPr>
-            </a:pPr>
-            <a:r>
-              <a:t>Our system scores each student's risk of dropping out. Only students who need fee help appear. School staff can see the reasons behind each score.</a:t>
-            </a:r>
-          </a:p>
-          <a:p>
-            <a:pPr algn="l">
-              <a:spcBef>
-                <a:spcPts val="600"/>
-              </a:spcBef>
-              <a:defRPr sz="800" b="0">
-                <a:solidFill>
-                  <a:srgbClr val="14213D"/>
-                </a:solidFill>
-                <a:latin typeface="Calibri"/>
-              </a:defRPr>
-            </a:pPr>
-            <a:endParaRPr/>
-          </a:p>
-          <a:p>
-            <a:pPr algn="l">
-              <a:spcBef>
-                <a:spcPts val="600"/>
+                <a:spcPts val="2200"/>
               </a:spcBef>
               <a:defRPr sz="1500" b="1">
                 <a:solidFill>
@@ -5296,52 +5551,16 @@
               </a:defRPr>
             </a:pPr>
             <a:r>
-              <a:t>Every shilling goes directly to the school's fee account. ElimuMatch does not take a cut.</a:t>
-            </a:r>
-          </a:p>
-        </p:txBody>
-      </p:sp>
-      <p:sp>
-        <p:nvSpPr>
-          <p:cNvPr id="8" name="TextBox 7"/>
-          <p:cNvSpPr txBox="1"/>
-          <p:nvPr/>
-        </p:nvSpPr>
-        <p:spPr>
-          <a:xfrm>
-            <a:off x="640080" y="6400800"/>
-            <a:ext cx="10972800" cy="246221"/>
-          </a:xfrm>
-          <a:prstGeom prst="rect">
-            <a:avLst/>
-          </a:prstGeom>
-          <a:noFill/>
-        </p:spPr>
-        <p:txBody>
-          <a:bodyPr wrap="square">
-            <a:spAutoFit/>
-          </a:bodyPr>
-          <a:lstStyle/>
-          <a:p>
-            <a:pPr algn="l">
-              <a:defRPr sz="1000" b="0">
-                <a:solidFill>
-                  <a:srgbClr val="5C6B73"/>
-                </a:solidFill>
-                <a:latin typeface="Calibri"/>
-              </a:defRPr>
-            </a:pPr>
-            <a:r>
               <a:rPr dirty="0"/>
-              <a:t>Privacy: </a:t>
-            </a:r>
-            <a:r>
-              <a:rPr lang="en-GB" dirty="0"/>
-              <a:t>D</a:t>
+              <a:t>Every shilling goes directly to the school's fee account. </a:t>
+            </a:r>
+            <a:r>
+              <a:rPr dirty="0" err="1"/>
+              <a:t>ElimuMatch</a:t>
             </a:r>
             <a:r>
               <a:rPr dirty="0"/>
-              <a:t>onors see anonymized profiles only. Student identities are protected. </a:t>
+              <a:t> does not take a cut.</a:t>
             </a:r>
           </a:p>
         </p:txBody>
@@ -5534,14 +5753,103 @@
               </a:defRPr>
             </a:pPr>
             <a:r>
-              <a:t>A donor chooses where to give, pays school fees, and gets a receipt</a:t>
+              <a:rPr dirty="0"/>
+              <a:t>A helper chooses where to give, pays school fees, and gets a receipt</a:t>
+            </a:r>
+          </a:p>
+        </p:txBody>
+      </p:sp>
+      <p:sp>
+        <p:nvSpPr>
+          <p:cNvPr id="7" name="TextBox 6"/>
+          <p:cNvSpPr txBox="1"/>
+          <p:nvPr/>
+        </p:nvSpPr>
+        <p:spPr>
+          <a:xfrm>
+            <a:off x="640080" y="4754880"/>
+            <a:ext cx="10972800" cy="1097280"/>
+          </a:xfrm>
+          <a:prstGeom prst="rect">
+            <a:avLst/>
+          </a:prstGeom>
+          <a:noFill/>
+        </p:spPr>
+        <p:txBody>
+          <a:bodyPr wrap="square">
+            <a:spAutoFit/>
+          </a:bodyPr>
+          <a:lstStyle/>
+          <a:p>
+            <a:pPr algn="l">
+              <a:defRPr sz="1500" b="0">
+                <a:solidFill>
+                  <a:srgbClr val="14213D"/>
+                </a:solidFill>
+                <a:latin typeface="Calibri"/>
+              </a:defRPr>
+            </a:pPr>
+            <a:r>
+              <a:t>Every gift goes directly to the school's fee account. Oldest unpaid terms are cleared first.</a:t>
+            </a:r>
+          </a:p>
+          <a:p>
+            <a:pPr algn="l">
+              <a:spcBef>
+                <a:spcPts val="600"/>
+              </a:spcBef>
+              <a:defRPr sz="1500" b="0">
+                <a:solidFill>
+                  <a:srgbClr val="14213D"/>
+                </a:solidFill>
+                <a:latin typeface="Calibri"/>
+              </a:defRPr>
+            </a:pPr>
+            <a:r>
+              <a:t>Overpayments are blocked automatically, and every transaction is tracked and auditable.</a:t>
+            </a:r>
+          </a:p>
+        </p:txBody>
+      </p:sp>
+      <p:sp>
+        <p:nvSpPr>
+          <p:cNvPr id="8" name="TextBox 7"/>
+          <p:cNvSpPr txBox="1"/>
+          <p:nvPr/>
+        </p:nvSpPr>
+        <p:spPr>
+          <a:xfrm>
+            <a:off x="640080" y="6355080"/>
+            <a:ext cx="10972800" cy="411480"/>
+          </a:xfrm>
+          <a:prstGeom prst="rect">
+            <a:avLst/>
+          </a:prstGeom>
+          <a:noFill/>
+        </p:spPr>
+        <p:txBody>
+          <a:bodyPr wrap="square">
+            <a:spAutoFit/>
+          </a:bodyPr>
+          <a:lstStyle/>
+          <a:p>
+            <a:pPr algn="l">
+              <a:defRPr sz="1200" b="0">
+                <a:solidFill>
+                  <a:srgbClr val="14213D"/>
+                </a:solidFill>
+                <a:latin typeface="Calibri"/>
+              </a:defRPr>
+            </a:pPr>
+            <a:r>
+              <a:t>Live demo: jesyldah.github.io/ElimuMatch</a:t>
             </a:r>
           </a:p>
         </p:txBody>
       </p:sp>
       <p:pic>
         <p:nvPicPr>
-          <p:cNvPr id="6" name="Picture 5" descr="10_gift_journey.png"/>
+          <p:cNvPr id="9" name="Picture 8" descr="10_gift_journey.png"/>
           <p:cNvPicPr>
             <a:picLocks noChangeAspect="1"/>
           </p:cNvPicPr>
@@ -5555,102 +5863,14 @@
         </p:blipFill>
         <p:spPr>
           <a:xfrm>
-            <a:off x="1280160" y="1417320"/>
-            <a:ext cx="8500188" cy="3200400"/>
+            <a:off x="640080" y="1417320"/>
+            <a:ext cx="7795627" cy="3200400"/>
           </a:xfrm>
           <a:prstGeom prst="rect">
             <a:avLst/>
           </a:prstGeom>
         </p:spPr>
       </p:pic>
-      <p:sp>
-        <p:nvSpPr>
-          <p:cNvPr id="7" name="TextBox 6"/>
-          <p:cNvSpPr txBox="1"/>
-          <p:nvPr/>
-        </p:nvSpPr>
-        <p:spPr>
-          <a:xfrm>
-            <a:off x="640080" y="4754880"/>
-            <a:ext cx="10972800" cy="1097280"/>
-          </a:xfrm>
-          <a:prstGeom prst="rect">
-            <a:avLst/>
-          </a:prstGeom>
-          <a:noFill/>
-        </p:spPr>
-        <p:txBody>
-          <a:bodyPr wrap="square">
-            <a:spAutoFit/>
-          </a:bodyPr>
-          <a:lstStyle/>
-          <a:p>
-            <a:pPr algn="l">
-              <a:defRPr sz="1500" b="0">
-                <a:solidFill>
-                  <a:srgbClr val="14213D"/>
-                </a:solidFill>
-                <a:latin typeface="Calibri"/>
-              </a:defRPr>
-            </a:pPr>
-            <a:r>
-              <a:t>Every gift goes directly to the school's fee account. Oldest unpaid terms are cleared first.</a:t>
-            </a:r>
-          </a:p>
-          <a:p>
-            <a:pPr algn="l">
-              <a:spcBef>
-                <a:spcPts val="600"/>
-              </a:spcBef>
-              <a:defRPr sz="1500" b="0">
-                <a:solidFill>
-                  <a:srgbClr val="14213D"/>
-                </a:solidFill>
-                <a:latin typeface="Calibri"/>
-              </a:defRPr>
-            </a:pPr>
-            <a:r>
-              <a:t>Overpayments are blocked automatically, and every transaction is tracked and auditable.</a:t>
-            </a:r>
-          </a:p>
-        </p:txBody>
-      </p:sp>
-      <p:sp>
-        <p:nvSpPr>
-          <p:cNvPr id="8" name="TextBox 7"/>
-          <p:cNvSpPr txBox="1"/>
-          <p:nvPr/>
-        </p:nvSpPr>
-        <p:spPr>
-          <a:xfrm>
-            <a:off x="640080" y="6400800"/>
-            <a:ext cx="10972800" cy="365760"/>
-          </a:xfrm>
-          <a:prstGeom prst="rect">
-            <a:avLst/>
-          </a:prstGeom>
-          <a:noFill/>
-        </p:spPr>
-        <p:txBody>
-          <a:bodyPr wrap="square">
-            <a:spAutoFit/>
-          </a:bodyPr>
-          <a:lstStyle/>
-          <a:p>
-            <a:pPr algn="l">
-              <a:defRPr sz="1000" b="0">
-                <a:solidFill>
-                  <a:srgbClr val="5C6B73"/>
-                </a:solidFill>
-                <a:latin typeface="Calibri"/>
-              </a:defRPr>
-            </a:pPr>
-            <a:r>
-              <a:t>Live demo: jesyldah.github.io/ElimuMatch</a:t>
-            </a:r>
-          </a:p>
-        </p:txBody>
-      </p:sp>
     </p:spTree>
   </p:cSld>
   <p:clrMapOvr>
@@ -5816,7 +6036,7 @@
         </p:nvSpPr>
         <p:spPr>
           <a:xfrm>
-            <a:off x="640080" y="640080"/>
+            <a:off x="640080" y="462042"/>
             <a:ext cx="10972800" cy="731520"/>
           </a:xfrm>
           <a:prstGeom prst="rect">
@@ -5839,6 +6059,7 @@
               </a:defRPr>
             </a:pPr>
             <a:r>
+              <a:rPr dirty="0"/>
               <a:t>Our system identifies about two out of three students who would drop out, twice the nearest alternative</a:t>
             </a:r>
           </a:p>
@@ -5860,8 +6081,8 @@
         </p:blipFill>
         <p:spPr>
           <a:xfrm>
-            <a:off x="640080" y="1463040"/>
-            <a:ext cx="6400800" cy="4367912"/>
+            <a:off x="457200" y="1454436"/>
+            <a:ext cx="6766560" cy="4292838"/>
           </a:xfrm>
           <a:prstGeom prst="rect">
             <a:avLst/>
@@ -5876,8 +6097,8 @@
         </p:nvSpPr>
         <p:spPr>
           <a:xfrm>
-            <a:off x="7498079" y="1463040"/>
-            <a:ext cx="4114800" cy="4114800"/>
+            <a:off x="7498080" y="1454436"/>
+            <a:ext cx="4114800" cy="2764859"/>
           </a:xfrm>
           <a:prstGeom prst="rect">
             <a:avLst/>
@@ -5899,13 +6120,14 @@
               </a:defRPr>
             </a:pPr>
             <a:r>
+              <a:rPr dirty="0"/>
               <a:t>We tested four different approaches.</a:t>
             </a:r>
           </a:p>
           <a:p>
             <a:pPr algn="l">
               <a:spcBef>
-                <a:spcPts val="600"/>
+                <a:spcPts val="1600"/>
               </a:spcBef>
               <a:defRPr sz="1500" b="0">
                 <a:solidFill>
@@ -5915,27 +6137,14 @@
               </a:defRPr>
             </a:pPr>
             <a:r>
+              <a:rPr dirty="0"/>
               <a:t>Logistic Regression is the one we selected: it catches about 67% of students who later drop out. Gradient Boosting catches only about 33%.</a:t>
             </a:r>
           </a:p>
           <a:p>
             <a:pPr algn="l">
               <a:spcBef>
-                <a:spcPts val="600"/>
-              </a:spcBef>
-              <a:defRPr sz="1000" b="0">
-                <a:solidFill>
-                  <a:srgbClr val="14213D"/>
-                </a:solidFill>
-                <a:latin typeface="Calibri"/>
-              </a:defRPr>
-            </a:pPr>
-            <a:endParaRPr/>
-          </a:p>
-          <a:p>
-            <a:pPr algn="l">
-              <a:spcBef>
-                <a:spcPts val="600"/>
+                <a:spcPts val="1800"/>
               </a:spcBef>
               <a:defRPr sz="1500" b="1">
                 <a:solidFill>
@@ -5945,27 +6154,14 @@
               </a:defRPr>
             </a:pPr>
             <a:r>
+              <a:rPr dirty="0"/>
               <a:t>The strongest warning signs are health problems, family economic pressure, and falling grades.</a:t>
             </a:r>
           </a:p>
           <a:p>
-            <a:pPr algn="l">
+            <a:pPr algn="just">
               <a:spcBef>
-                <a:spcPts val="600"/>
-              </a:spcBef>
-              <a:defRPr sz="1000" b="0">
-                <a:solidFill>
-                  <a:srgbClr val="14213D"/>
-                </a:solidFill>
-                <a:latin typeface="Calibri"/>
-              </a:defRPr>
-            </a:pPr>
-            <a:endParaRPr/>
-          </a:p>
-          <a:p>
-            <a:pPr algn="l">
-              <a:spcBef>
-                <a:spcPts val="600"/>
+                <a:spcPts val="1600"/>
               </a:spcBef>
               <a:defRPr sz="1400" b="0">
                 <a:solidFill>
@@ -5975,44 +6171,8 @@
               </a:defRPr>
             </a:pPr>
             <a:r>
-              <a:t>School staff see why each student is flagged, so they can take informed action. Donors see only a simple, clear profile.</a:t>
-            </a:r>
-          </a:p>
-        </p:txBody>
-      </p:sp>
-      <p:sp>
-        <p:nvSpPr>
-          <p:cNvPr id="8" name="TextBox 7"/>
-          <p:cNvSpPr txBox="1"/>
-          <p:nvPr/>
-        </p:nvSpPr>
-        <p:spPr>
-          <a:xfrm>
-            <a:off x="640080" y="6400800"/>
-            <a:ext cx="10972800" cy="246221"/>
-          </a:xfrm>
-          <a:prstGeom prst="rect">
-            <a:avLst/>
-          </a:prstGeom>
-          <a:noFill/>
-        </p:spPr>
-        <p:txBody>
-          <a:bodyPr wrap="square">
-            <a:spAutoFit/>
-          </a:bodyPr>
-          <a:lstStyle/>
-          <a:p>
-            <a:pPr algn="l">
-              <a:defRPr sz="1000" b="0">
-                <a:solidFill>
-                  <a:srgbClr val="5C6B73"/>
-                </a:solidFill>
-                <a:latin typeface="Calibri"/>
-              </a:defRPr>
-            </a:pPr>
-            <a:r>
               <a:rPr dirty="0"/>
-              <a:t>Results from proof-of-concept data (1,000 students). Real school validation is the next step.</a:t>
+              <a:t>School staff see why each student is flagged, so they can take informed action. Helpers see only a simple, clear profile.</a:t>
             </a:r>
           </a:p>
         </p:txBody>
@@ -6182,7 +6342,7 @@
         </p:nvSpPr>
         <p:spPr>
           <a:xfrm>
-            <a:off x="640080" y="640080"/>
+            <a:off x="640080" y="621792"/>
             <a:ext cx="10972800" cy="731520"/>
           </a:xfrm>
           <a:prstGeom prst="rect">
@@ -6205,6 +6365,7 @@
               </a:defRPr>
             </a:pPr>
             <a:r>
+              <a:rPr dirty="0"/>
               <a:t>An 8-school pilot returns about KES 2.6 for every KES 1 of platform cost</a:t>
             </a:r>
           </a:p>
@@ -6227,7 +6388,7 @@
         <p:spPr>
           <a:xfrm>
             <a:off x="457200" y="1463040"/>
-            <a:ext cx="5486400" cy="3318201"/>
+            <a:ext cx="5486400" cy="3389687"/>
           </a:xfrm>
           <a:prstGeom prst="rect">
             <a:avLst/>
@@ -6243,7 +6404,7 @@
         <p:spPr>
           <a:xfrm>
             <a:off x="6400800" y="1463040"/>
-            <a:ext cx="5303520" cy="4114800"/>
+            <a:ext cx="5303520" cy="3616375"/>
           </a:xfrm>
           <a:prstGeom prst="rect">
             <a:avLst/>
@@ -6265,6 +6426,7 @@
               </a:defRPr>
             </a:pPr>
             <a:r>
+              <a:rPr dirty="0"/>
               <a:t>Year-1 pilot: 8 schools, about 1,000 students</a:t>
             </a:r>
           </a:p>
@@ -6280,7 +6442,7 @@
                 <a:latin typeface="Calibri"/>
               </a:defRPr>
             </a:pPr>
-            <a:endParaRPr/>
+            <a:endParaRPr dirty="0"/>
           </a:p>
           <a:p>
             <a:pPr algn="l">
@@ -6295,6 +6457,7 @@
               </a:defRPr>
             </a:pPr>
             <a:r>
+              <a:rPr dirty="0"/>
               <a:t>It costs about KES 2.0M to set up and run the platform for one year.</a:t>
             </a:r>
           </a:p>
@@ -6311,7 +6474,8 @@
               </a:defRPr>
             </a:pPr>
             <a:r>
-              <a:t>Donor gifts of about KES 4.0M pass through to schools separately.</a:t>
+              <a:rPr dirty="0"/>
+              <a:t>Helper gifts of about KES 4.0M pass through to schools separately.</a:t>
             </a:r>
           </a:p>
           <a:p>
@@ -6327,6 +6491,7 @@
               </a:defRPr>
             </a:pPr>
             <a:r>
+              <a:rPr dirty="0"/>
               <a:t>The estimated benefits total about KES 5.2M from better targeting, fewer dropouts, and staff time saved.</a:t>
             </a:r>
           </a:p>
@@ -6342,7 +6507,55 @@
                 <a:latin typeface="Calibri"/>
               </a:defRPr>
             </a:pPr>
-            <a:endParaRPr/>
+            <a:endParaRPr dirty="0"/>
+          </a:p>
+          <a:p>
+            <a:pPr algn="just">
+              <a:spcBef>
+                <a:spcPts val="600"/>
+              </a:spcBef>
+              <a:defRPr sz="1400" b="0">
+                <a:solidFill>
+                  <a:srgbClr val="5C6B73"/>
+                </a:solidFill>
+                <a:latin typeface="Calibri"/>
+              </a:defRPr>
+            </a:pPr>
+            <a:r>
+              <a:rPr dirty="0"/>
+              <a:t>Conservative estimate: roughly break-even.</a:t>
+            </a:r>
+          </a:p>
+          <a:p>
+            <a:pPr algn="l">
+              <a:spcBef>
+                <a:spcPts val="600"/>
+              </a:spcBef>
+              <a:defRPr sz="1600" b="1">
+                <a:solidFill>
+                  <a:srgbClr val="1B7A5A"/>
+                </a:solidFill>
+                <a:latin typeface="Calibri"/>
+              </a:defRPr>
+            </a:pPr>
+            <a:r>
+              <a:rPr dirty="0"/>
+              <a:t>Base case: 2.6x return.  Best case: 5.4x.</a:t>
+            </a:r>
+          </a:p>
+          <a:p>
+            <a:pPr algn="l">
+              <a:spcBef>
+                <a:spcPts val="600"/>
+              </a:spcBef>
+              <a:defRPr sz="800" b="0">
+                <a:solidFill>
+                  <a:srgbClr val="14213D"/>
+                </a:solidFill>
+                <a:latin typeface="Calibri"/>
+              </a:defRPr>
+            </a:pPr>
+            <a:endParaRPr dirty="0"/>
           </a:p>
           <a:p>
             <a:pPr algn="l">
@@ -6351,102 +6564,15 @@
               </a:spcBef>
               <a:defRPr sz="1400" b="0">
                 <a:solidFill>
-                  <a:srgbClr val="5C6B73"/>
-                </a:solidFill>
-                <a:latin typeface="Calibri"/>
-              </a:defRPr>
-            </a:pPr>
-            <a:r>
-              <a:t>Conservative estimate: roughly break-even.</a:t>
-            </a:r>
-          </a:p>
-          <a:p>
-            <a:pPr algn="l">
-              <a:spcBef>
-                <a:spcPts val="600"/>
-              </a:spcBef>
-              <a:defRPr sz="1600" b="1">
-                <a:solidFill>
-                  <a:srgbClr val="1B7A5A"/>
-                </a:solidFill>
-                <a:latin typeface="Calibri"/>
-              </a:defRPr>
-            </a:pPr>
-            <a:r>
-              <a:t>Base case: 2.6x return.  Best case: 5.4x.</a:t>
-            </a:r>
-          </a:p>
-          <a:p>
-            <a:pPr algn="l">
-              <a:spcBef>
-                <a:spcPts val="600"/>
-              </a:spcBef>
-              <a:defRPr sz="800" b="0">
-                <a:solidFill>
                   <a:srgbClr val="14213D"/>
                 </a:solidFill>
                 <a:latin typeface="Calibri"/>
               </a:defRPr>
             </a:pPr>
-            <a:endParaRPr/>
-          </a:p>
-          <a:p>
-            <a:pPr algn="l">
-              <a:spcBef>
-                <a:spcPts val="600"/>
-              </a:spcBef>
-              <a:defRPr sz="1400" b="0">
-                <a:solidFill>
-                  <a:srgbClr val="14213D"/>
-                </a:solidFill>
-                <a:latin typeface="Calibri"/>
-              </a:defRPr>
-            </a:pPr>
-            <a:r>
+            <a:r>
+              <a:rPr dirty="0"/>
               <a:t>We measure success by whether priority students actually receive gifts, whether payments land without errors, and whether helped students stay in school.</a:t>
             </a:r>
-          </a:p>
-        </p:txBody>
-      </p:sp>
-      <p:sp>
-        <p:nvSpPr>
-          <p:cNvPr id="8" name="TextBox 7"/>
-          <p:cNvSpPr txBox="1"/>
-          <p:nvPr/>
-        </p:nvSpPr>
-        <p:spPr>
-          <a:xfrm>
-            <a:off x="640080" y="6400800"/>
-            <a:ext cx="10972800" cy="246221"/>
-          </a:xfrm>
-          <a:prstGeom prst="rect">
-            <a:avLst/>
-          </a:prstGeom>
-          <a:noFill/>
-        </p:spPr>
-        <p:txBody>
-          <a:bodyPr wrap="square">
-            <a:spAutoFit/>
-          </a:bodyPr>
-          <a:lstStyle/>
-          <a:p>
-            <a:pPr algn="l">
-              <a:defRPr sz="1000" b="0">
-                <a:solidFill>
-                  <a:srgbClr val="5C6B73"/>
-                </a:solidFill>
-                <a:latin typeface="Calibri"/>
-              </a:defRPr>
-            </a:pPr>
-            <a:r>
-              <a:rPr dirty="0"/>
-              <a:t>All figures are estimates for an illustrative pilot, not audited financials. Benefits depend on real outcomes</a:t>
-            </a:r>
-            <a:r>
-              <a:rPr lang="en-GB" dirty="0"/>
-              <a:t>.</a:t>
-            </a:r>
-            <a:endParaRPr dirty="0"/>
           </a:p>
         </p:txBody>
       </p:sp>
@@ -6579,7 +6705,7 @@
         </p:nvSpPr>
         <p:spPr>
           <a:xfrm>
-            <a:off x="640080" y="201168"/>
+            <a:off x="411480" y="262999"/>
             <a:ext cx="10972800" cy="365760"/>
           </a:xfrm>
           <a:prstGeom prst="rect">
@@ -6602,6 +6728,7 @@
               </a:defRPr>
             </a:pPr>
             <a:r>
+              <a:rPr dirty="0"/>
               <a:t>IMPLEMENTATION ROADMAP</a:t>
             </a:r>
           </a:p>
@@ -6615,7 +6742,7 @@
         </p:nvSpPr>
         <p:spPr>
           <a:xfrm>
-            <a:off x="640080" y="640080"/>
+            <a:off x="411480" y="679704"/>
             <a:ext cx="10972800" cy="731520"/>
           </a:xfrm>
           <a:prstGeom prst="rect">
@@ -6638,7 +6765,8 @@
               </a:defRPr>
             </a:pPr>
             <a:r>
-              <a:t>We scale only if the pilot clears three decision gates</a:t>
+              <a:rPr dirty="0"/>
+              <a:t>Our pilot runs through six stages and proceeds only if hard results clear</a:t>
             </a:r>
           </a:p>
         </p:txBody>
@@ -6780,7 +6908,7 @@
         <p:spPr>
           <a:xfrm>
             <a:off x="502920" y="4343400"/>
-            <a:ext cx="1600200" cy="261610"/>
+            <a:ext cx="1600200" cy="320040"/>
           </a:xfrm>
           <a:prstGeom prst="rect">
             <a:avLst/>
@@ -6802,14 +6930,8 @@
               </a:defRPr>
             </a:pPr>
             <a:r>
-              <a:rPr dirty="0"/>
-              <a:t>Months 0-</a:t>
-            </a:r>
-            <a:r>
-              <a:rPr lang="en-GB" dirty="0"/>
-              <a:t>4</a:t>
-            </a:r>
-            <a:endParaRPr dirty="0"/>
+              <a:t>Months 0-4</a:t>
+            </a:r>
           </a:p>
         </p:txBody>
       </p:sp>
@@ -6888,7 +7010,6 @@
               </a:defRPr>
             </a:pPr>
             <a:r>
-              <a:rPr dirty="0"/>
               <a:t>2. Partner Data</a:t>
             </a:r>
           </a:p>
@@ -7272,7 +7393,7 @@
               </a:defRPr>
             </a:pPr>
             <a:r>
-              <a:t>Donors give through</a:t>
+              <a:t>Helpers give through</a:t>
             </a:r>
             <a:br/>
             <a:r>
@@ -8145,42 +8266,6 @@
             </a:pPr>
             <a:r>
               <a:t>Helped students stay in school longer within two terms</a:t>
-            </a:r>
-          </a:p>
-        </p:txBody>
-      </p:sp>
-      <p:sp>
-        <p:nvSpPr>
-          <p:cNvPr id="43" name="TextBox 42"/>
-          <p:cNvSpPr txBox="1"/>
-          <p:nvPr/>
-        </p:nvSpPr>
-        <p:spPr>
-          <a:xfrm>
-            <a:off x="640080" y="6400800"/>
-            <a:ext cx="10972800" cy="365760"/>
-          </a:xfrm>
-          <a:prstGeom prst="rect">
-            <a:avLst/>
-          </a:prstGeom>
-          <a:noFill/>
-        </p:spPr>
-        <p:txBody>
-          <a:bodyPr wrap="square">
-            <a:spAutoFit/>
-          </a:bodyPr>
-          <a:lstStyle/>
-          <a:p>
-            <a:pPr algn="l">
-              <a:defRPr sz="1000" b="0">
-                <a:solidFill>
-                  <a:srgbClr val="5C6B73"/>
-                </a:solidFill>
-                <a:latin typeface="Calibri"/>
-              </a:defRPr>
-            </a:pPr>
-            <a:r>
-              <a:t>Every gate requires a formal review. Capital unlocks the next stage only when the previous one clears.</a:t>
             </a:r>
           </a:p>
         </p:txBody>
@@ -8390,8 +8475,8 @@
         </p:nvSpPr>
         <p:spPr>
           <a:xfrm>
-            <a:off x="2286000" y="2834640"/>
-            <a:ext cx="7315200" cy="2560320"/>
+            <a:off x="2438247" y="2828109"/>
+            <a:ext cx="7315200" cy="2328843"/>
           </a:xfrm>
           <a:prstGeom prst="rect">
             <a:avLst/>
@@ -8413,7 +8498,53 @@
               </a:defRPr>
             </a:pPr>
             <a:r>
-              <a:t>✓  About KES 2.0M for platform setup and operations (donor gifts go to schools separately).</a:t>
+              <a:rPr lang="en-GB" dirty="0"/>
+              <a:t>What the funding will unlock:</a:t>
+            </a:r>
+          </a:p>
+          <a:p>
+            <a:pPr algn="l">
+              <a:defRPr sz="1600" b="0">
+                <a:solidFill>
+                  <a:srgbClr val="FFFFFF"/>
+                </a:solidFill>
+                <a:latin typeface="Calibri"/>
+              </a:defRPr>
+            </a:pPr>
+            <a:endParaRPr lang="en-GB" dirty="0"/>
+          </a:p>
+          <a:p>
+            <a:pPr algn="l">
+              <a:defRPr sz="1600" b="0">
+                <a:solidFill>
+                  <a:srgbClr val="FFFFFF"/>
+                </a:solidFill>
+                <a:latin typeface="Calibri"/>
+              </a:defRPr>
+            </a:pPr>
+            <a:r>
+              <a:rPr dirty="0"/>
+              <a:t>✓  </a:t>
+            </a:r>
+            <a:r>
+              <a:rPr lang="en-GB" dirty="0"/>
+              <a:t>P</a:t>
+            </a:r>
+            <a:r>
+              <a:rPr dirty="0" err="1"/>
+              <a:t>latform</a:t>
+            </a:r>
+            <a:r>
+              <a:rPr dirty="0"/>
+              <a:t> setup and operations (helper gifts go to schools </a:t>
+            </a:r>
+            <a:r>
+              <a:rPr lang="en-GB" dirty="0"/>
+              <a:t>directly</a:t>
+            </a:r>
+            <a:r>
+              <a:rPr dirty="0"/>
+              <a:t>).</a:t>
             </a:r>
           </a:p>
           <a:p>
@@ -8429,6 +8560,7 @@
               </a:defRPr>
             </a:pPr>
             <a:r>
+              <a:rPr dirty="0"/>
               <a:t>✓  A part-time analyst and school liaison to run the pilot.</a:t>
             </a:r>
           </a:p>
@@ -8445,6 +8577,7 @@
               </a:defRPr>
             </a:pPr>
             <a:r>
+              <a:rPr dirty="0"/>
               <a:t>✓  Access to partner school records under signed agreements.</a:t>
             </a:r>
           </a:p>
@@ -8461,6 +8594,7 @@
               </a:defRPr>
             </a:pPr>
             <a:r>
+              <a:rPr dirty="0"/>
               <a:t>✓  Live fee giving with human review of every student list before it is published.</a:t>
             </a:r>
           </a:p>
@@ -8477,7 +8611,16 @@
               </a:defRPr>
             </a:pPr>
             <a:r>
-              <a:t>✓  A decision to expand only after pilot results justify it.</a:t>
+              <a:rPr dirty="0"/>
+              <a:t>✓  A decision to expand </a:t>
+            </a:r>
+            <a:r>
+              <a:rPr lang="en-GB" dirty="0"/>
+              <a:t>- </a:t>
+            </a:r>
+            <a:r>
+              <a:rPr dirty="0"/>
+              <a:t>only after pilot results justify it.</a:t>
             </a:r>
           </a:p>
         </p:txBody>
@@ -8490,7 +8633,7 @@
         </p:nvSpPr>
         <p:spPr>
           <a:xfrm>
-            <a:off x="914400" y="5486400"/>
+            <a:off x="914400" y="5852160"/>
             <a:ext cx="10058400" cy="731520"/>
           </a:xfrm>
           <a:prstGeom prst="rect">
@@ -8513,10 +8656,14 @@
               </a:defRPr>
             </a:pPr>
             <a:r>
+              <a:rPr dirty="0"/>
               <a:t>We can direct fee support to the students most likely to leave school,</a:t>
             </a:r>
-            <a:br/>
-            <a:r>
+            <a:br>
+              <a:rPr dirty="0"/>
+            </a:br>
+            <a:r>
+              <a:rPr dirty="0"/>
               <a:t>replacing guesswork with transparent, auditable matching.</a:t>
             </a:r>
           </a:p>

</xml_diff>

<commit_message>
Final submission sync: pitch, investor brief, and Support Hub brand casing.
Lock in the delivered deck and brief, and show ElimuMatch (not ELIMUMATCH) on the Support Hub header.

Co-authored-by: Cursor <cursoragent@cursor.com>
</commit_message>
<xml_diff>
--- a/ElimuMatch_Executive_Pitch.pptx
+++ b/ElimuMatch_Executive_Pitch.pptx
@@ -137,12 +137,12 @@
   <pc:docChgLst>
     <pc:chgData name="Jess W" userId="0a9e92bfc7a9bd4f" providerId="LiveId" clId="{44A44528-DB36-4F8C-9869-CF35F0FB3EAC}"/>
     <pc:docChg chg="undo redo custSel addSld delSld modSld">
-      <pc:chgData name="Jess W" userId="0a9e92bfc7a9bd4f" providerId="LiveId" clId="{44A44528-DB36-4F8C-9869-CF35F0FB3EAC}" dt="2026-09-08T19:51:01.266" v="663" actId="1076"/>
+      <pc:chgData name="Jess W" userId="0a9e92bfc7a9bd4f" providerId="LiveId" clId="{44A44528-DB36-4F8C-9869-CF35F0FB3EAC}" dt="2026-09-09T14:40:38.539" v="698" actId="20577"/>
       <pc:docMkLst>
         <pc:docMk/>
       </pc:docMkLst>
       <pc:sldChg chg="addSp delSp modSp mod">
-        <pc:chgData name="Jess W" userId="0a9e92bfc7a9bd4f" providerId="LiveId" clId="{44A44528-DB36-4F8C-9869-CF35F0FB3EAC}" dt="2026-09-08T10:06:32.233" v="96" actId="20577"/>
+        <pc:chgData name="Jess W" userId="0a9e92bfc7a9bd4f" providerId="LiveId" clId="{44A44528-DB36-4F8C-9869-CF35F0FB3EAC}" dt="2026-09-09T14:40:38.539" v="698" actId="20577"/>
         <pc:sldMkLst>
           <pc:docMk/>
           <pc:sldMk cId="0" sldId="256"/>
@@ -164,7 +164,7 @@
           </ac:spMkLst>
         </pc:spChg>
         <pc:spChg chg="mod">
-          <ac:chgData name="Jess W" userId="0a9e92bfc7a9bd4f" providerId="LiveId" clId="{44A44528-DB36-4F8C-9869-CF35F0FB3EAC}" dt="2026-09-08T10:05:37.196" v="73" actId="1076"/>
+          <ac:chgData name="Jess W" userId="0a9e92bfc7a9bd4f" providerId="LiveId" clId="{44A44528-DB36-4F8C-9869-CF35F0FB3EAC}" dt="2026-09-09T14:40:38.539" v="698" actId="20577"/>
           <ac:spMkLst>
             <pc:docMk/>
             <pc:sldMk cId="0" sldId="256"/>
@@ -454,13 +454,21 @@
         </pc:spChg>
       </pc:sldChg>
       <pc:sldChg chg="modSp mod">
-        <pc:chgData name="Jess W" userId="0a9e92bfc7a9bd4f" providerId="LiveId" clId="{44A44528-DB36-4F8C-9869-CF35F0FB3EAC}" dt="2026-09-08T19:51:01.266" v="663" actId="1076"/>
+        <pc:chgData name="Jess W" userId="0a9e92bfc7a9bd4f" providerId="LiveId" clId="{44A44528-DB36-4F8C-9869-CF35F0FB3EAC}" dt="2026-09-09T08:23:00.375" v="687" actId="20577"/>
         <pc:sldMkLst>
           <pc:docMk/>
           <pc:sldMk cId="0" sldId="264"/>
         </pc:sldMkLst>
         <pc:spChg chg="mod">
-          <ac:chgData name="Jess W" userId="0a9e92bfc7a9bd4f" providerId="LiveId" clId="{44A44528-DB36-4F8C-9869-CF35F0FB3EAC}" dt="2026-09-08T19:51:01.266" v="663" actId="1076"/>
+          <ac:chgData name="Jess W" userId="0a9e92bfc7a9bd4f" providerId="LiveId" clId="{44A44528-DB36-4F8C-9869-CF35F0FB3EAC}" dt="2026-09-09T08:22:07.307" v="683" actId="20577"/>
+          <ac:spMkLst>
+            <pc:docMk/>
+            <pc:sldMk cId="0" sldId="264"/>
+            <ac:spMk id="5" creationId="{00000000-0000-0000-0000-000000000000}"/>
+          </ac:spMkLst>
+        </pc:spChg>
+        <pc:spChg chg="mod">
+          <ac:chgData name="Jess W" userId="0a9e92bfc7a9bd4f" providerId="LiveId" clId="{44A44528-DB36-4F8C-9869-CF35F0FB3EAC}" dt="2026-09-09T08:23:00.375" v="687" actId="20577"/>
           <ac:spMkLst>
             <pc:docMk/>
             <pc:sldMk cId="0" sldId="264"/>
@@ -667,7 +675,7 @@
           <a:p>
             <a:fld id="{5BCAD085-E8A6-8845-BD4E-CB4CCA059FC4}" type="datetimeFigureOut">
               <a:rPr lang="en-US" smtClean="0"/>
-              <a:t>9/8/2026</a:t>
+              <a:t>9/9/2026</a:t>
             </a:fld>
             <a:endParaRPr lang="en-US"/>
           </a:p>
@@ -835,7 +843,7 @@
           <a:p>
             <a:fld id="{5BCAD085-E8A6-8845-BD4E-CB4CCA059FC4}" type="datetimeFigureOut">
               <a:rPr lang="en-US" smtClean="0"/>
-              <a:t>9/8/2026</a:t>
+              <a:t>9/9/2026</a:t>
             </a:fld>
             <a:endParaRPr lang="en-US"/>
           </a:p>
@@ -1013,7 +1021,7 @@
           <a:p>
             <a:fld id="{5BCAD085-E8A6-8845-BD4E-CB4CCA059FC4}" type="datetimeFigureOut">
               <a:rPr lang="en-US" smtClean="0"/>
-              <a:t>9/8/2026</a:t>
+              <a:t>9/9/2026</a:t>
             </a:fld>
             <a:endParaRPr lang="en-US"/>
           </a:p>
@@ -1181,7 +1189,7 @@
           <a:p>
             <a:fld id="{5BCAD085-E8A6-8845-BD4E-CB4CCA059FC4}" type="datetimeFigureOut">
               <a:rPr lang="en-US" smtClean="0"/>
-              <a:t>9/8/2026</a:t>
+              <a:t>9/9/2026</a:t>
             </a:fld>
             <a:endParaRPr lang="en-US"/>
           </a:p>
@@ -1426,7 +1434,7 @@
           <a:p>
             <a:fld id="{5BCAD085-E8A6-8845-BD4E-CB4CCA059FC4}" type="datetimeFigureOut">
               <a:rPr lang="en-US" smtClean="0"/>
-              <a:t>9/8/2026</a:t>
+              <a:t>9/9/2026</a:t>
             </a:fld>
             <a:endParaRPr lang="en-US"/>
           </a:p>
@@ -1711,7 +1719,7 @@
           <a:p>
             <a:fld id="{5BCAD085-E8A6-8845-BD4E-CB4CCA059FC4}" type="datetimeFigureOut">
               <a:rPr lang="en-US" smtClean="0"/>
-              <a:t>9/8/2026</a:t>
+              <a:t>9/9/2026</a:t>
             </a:fld>
             <a:endParaRPr lang="en-US"/>
           </a:p>
@@ -2130,7 +2138,7 @@
           <a:p>
             <a:fld id="{5BCAD085-E8A6-8845-BD4E-CB4CCA059FC4}" type="datetimeFigureOut">
               <a:rPr lang="en-US" smtClean="0"/>
-              <a:t>9/8/2026</a:t>
+              <a:t>9/9/2026</a:t>
             </a:fld>
             <a:endParaRPr lang="en-US"/>
           </a:p>
@@ -2247,7 +2255,7 @@
           <a:p>
             <a:fld id="{5BCAD085-E8A6-8845-BD4E-CB4CCA059FC4}" type="datetimeFigureOut">
               <a:rPr lang="en-US" smtClean="0"/>
-              <a:t>9/8/2026</a:t>
+              <a:t>9/9/2026</a:t>
             </a:fld>
             <a:endParaRPr lang="en-US"/>
           </a:p>
@@ -2342,7 +2350,7 @@
           <a:p>
             <a:fld id="{5BCAD085-E8A6-8845-BD4E-CB4CCA059FC4}" type="datetimeFigureOut">
               <a:rPr lang="en-US" smtClean="0"/>
-              <a:t>9/8/2026</a:t>
+              <a:t>9/9/2026</a:t>
             </a:fld>
             <a:endParaRPr lang="en-US"/>
           </a:p>
@@ -2617,7 +2625,7 @@
           <a:p>
             <a:fld id="{5BCAD085-E8A6-8845-BD4E-CB4CCA059FC4}" type="datetimeFigureOut">
               <a:rPr lang="en-US" smtClean="0"/>
-              <a:t>9/8/2026</a:t>
+              <a:t>9/9/2026</a:t>
             </a:fld>
             <a:endParaRPr lang="en-US"/>
           </a:p>
@@ -2869,7 +2877,7 @@
           <a:p>
             <a:fld id="{5BCAD085-E8A6-8845-BD4E-CB4CCA059FC4}" type="datetimeFigureOut">
               <a:rPr lang="en-US" smtClean="0"/>
-              <a:t>9/8/2026</a:t>
+              <a:t>9/9/2026</a:t>
             </a:fld>
             <a:endParaRPr lang="en-US"/>
           </a:p>
@@ -3080,7 +3088,7 @@
           <a:p>
             <a:fld id="{5BCAD085-E8A6-8845-BD4E-CB4CCA059FC4}" type="datetimeFigureOut">
               <a:rPr lang="en-US" smtClean="0"/>
-              <a:t>9/8/2026</a:t>
+              <a:t>9/9/2026</a:t>
             </a:fld>
             <a:endParaRPr lang="en-US"/>
           </a:p>
@@ -3751,7 +3759,18 @@
             </a:r>
             <a:r>
               <a:rPr dirty="0"/>
-              <a:t>|  August 2026</a:t>
+              <a:t>|  </a:t>
+            </a:r>
+            <a:r>
+              <a:rPr lang="en-GB"/>
+              <a:t>September</a:t>
+            </a:r>
+            <a:r>
+              <a:t> </a:t>
+            </a:r>
+            <a:r>
+              <a:rPr dirty="0"/>
+              <a:t>2026</a:t>
             </a:r>
           </a:p>
         </p:txBody>
@@ -8436,7 +8455,7 @@
         <p:spPr>
           <a:xfrm>
             <a:off x="1371600" y="1463040"/>
-            <a:ext cx="9144000" cy="822960"/>
+            <a:ext cx="9144000" cy="769441"/>
           </a:xfrm>
           <a:prstGeom prst="rect">
             <a:avLst/>
@@ -8458,10 +8477,22 @@
               </a:defRPr>
             </a:pPr>
             <a:r>
-              <a:t>Fund an 8-school Year-1 pilot to prove</a:t>
-            </a:r>
-            <a:br/>
-            <a:r>
+              <a:rPr lang="en-GB" dirty="0" err="1"/>
+              <a:t>Ksh</a:t>
+            </a:r>
+            <a:r>
+              <a:rPr lang="en-GB" dirty="0"/>
+              <a:t>. 2 million to f</a:t>
+            </a:r>
+            <a:r>
+              <a:rPr dirty="0"/>
+              <a:t>und an 8-school Year-1 pilot to prove</a:t>
+            </a:r>
+            <a:br>
+              <a:rPr dirty="0"/>
+            </a:br>
+            <a:r>
+              <a:rPr dirty="0"/>
               <a:t>fee-support matching on real school data</a:t>
             </a:r>
           </a:p>
@@ -8616,11 +8647,19 @@
             </a:r>
             <a:r>
               <a:rPr lang="en-GB" dirty="0"/>
-              <a:t>- </a:t>
+              <a:t>(</a:t>
             </a:r>
             <a:r>
               <a:rPr dirty="0"/>
-              <a:t>only after pilot results justify it.</a:t>
+              <a:t>only after pilot results justify it</a:t>
+            </a:r>
+            <a:r>
+              <a:rPr lang="en-GB" dirty="0"/>
+              <a:t>)</a:t>
+            </a:r>
+            <a:r>
+              <a:rPr dirty="0"/>
+              <a:t>.</a:t>
             </a:r>
           </a:p>
         </p:txBody>

</xml_diff>